<commit_message>
Pitch deck: seeded demo data, real admin screenshots and walkthrough video
Adds capture.py (Playwright) that records screenshots and a walkthrough from the
local site, and rebuilds the deck with them (14 slides incl. embedded video).

Co-Authored-By: Claude Sonnet 5.5 <noreply@anthropic.com>
</commit_message>
<xml_diff>
--- a/docs/pitch/Temple_Platform_Demo.pptx
+++ b/docs/pitch/Temple_Platform_Demo.pptx
@@ -17,6 +17,8 @@
     <p:sldId id="265" r:id="rId16"/>
     <p:sldId id="266" r:id="rId17"/>
     <p:sldId id="267" r:id="rId18"/>
+    <p:sldId id="268" r:id="rId19"/>
+    <p:sldId id="269" r:id="rId20"/>
   </p:sldIdLst>
   <p:sldSz cx="12191695" cy="6858000" type="screen4x3"/>
   <p:notesSz cx="6858000" cy="9144000"/>
@@ -3474,7 +3476,7 @@
                 </a:solidFill>
                 <a:latin typeface="Georgia"/>
               </a:rPr>
-              <a:t>Three packages</a:t>
+              <a:t>How it is built</a:t>
             </a:r>
           </a:p>
         </p:txBody>
@@ -3513,7 +3515,7 @@
                 </a:solidFill>
                 <a:latin typeface="Calibri"/>
               </a:rPr>
-              <a:t>Same platform; choose what the temple needs today and grow later</a:t>
+              <a:t>Modern, tested, containerised: low cost to run, easy to hand over</a:t>
             </a:r>
           </a:p>
         </p:txBody>
@@ -3559,16 +3561,661 @@
       </p:sp>
       <p:sp>
         <p:nvSpPr>
-          <p:cNvPr id="6" name="Rectangle 5"/>
+          <p:cNvPr id="6" name="Rounded Rectangle 5"/>
           <p:cNvSpPr/>
           <p:nvPr/>
         </p:nvSpPr>
         <p:spPr>
           <a:xfrm>
-            <a:off x="548640" y="1554480"/>
-            <a:ext cx="3611880" cy="4572000"/>
-          </a:xfrm>
-          <a:prstGeom prst="rect">
+            <a:off x="548640" y="2011680"/>
+            <a:ext cx="2011680" cy="1188720"/>
+          </a:xfrm>
+          <a:prstGeom prst="roundRect">
+            <a:avLst/>
+          </a:prstGeom>
+          <a:solidFill>
+            <a:srgbClr val="FFFFFF"/>
+          </a:solidFill>
+          <a:ln w="12700">
+            <a:solidFill>
+              <a:srgbClr val="7B1A1A"/>
+            </a:solidFill>
+          </a:ln>
+          <a:effectLst/>
+        </p:spPr>
+        <p:style>
+          <a:lnRef idx="1">
+            <a:schemeClr val="accent1"/>
+          </a:lnRef>
+          <a:fillRef idx="3">
+            <a:schemeClr val="accent1"/>
+          </a:fillRef>
+          <a:effectRef idx="2">
+            <a:schemeClr val="accent1"/>
+          </a:effectRef>
+          <a:fontRef idx="minor">
+            <a:schemeClr val="lt1"/>
+          </a:fontRef>
+        </p:style>
+        <p:txBody>
+          <a:bodyPr rtlCol="0" anchor="ctr"/>
+          <a:lstStyle/>
+          <a:p>
+            <a:pPr algn="ctr"/>
+          </a:p>
+        </p:txBody>
+      </p:sp>
+      <p:sp>
+        <p:nvSpPr>
+          <p:cNvPr id="7" name="TextBox 6"/>
+          <p:cNvSpPr txBox="1"/>
+          <p:nvPr/>
+        </p:nvSpPr>
+        <p:spPr>
+          <a:xfrm>
+            <a:off x="548640" y="2011680"/>
+            <a:ext cx="2011680" cy="1188720"/>
+          </a:xfrm>
+          <a:prstGeom prst="rect">
+            <a:avLst/>
+          </a:prstGeom>
+          <a:noFill/>
+        </p:spPr>
+        <p:txBody>
+          <a:bodyPr wrap="square" anchor="ctr">
+            <a:spAutoFit/>
+          </a:bodyPr>
+          <a:lstStyle/>
+          <a:p>
+            <a:pPr algn="ctr">
+              <a:spcAft>
+                <a:spcPts val="600"/>
+              </a:spcAft>
+            </a:pPr>
+            <a:r>
+              <a:rPr sz="1300" b="1">
+                <a:solidFill>
+                  <a:srgbClr val="7B1A1A"/>
+                </a:solidFill>
+                <a:latin typeface="Calibri"/>
+              </a:rPr>
+              <a:t>Devotee / Staff</a:t>
+            </a:r>
+          </a:p>
+          <a:p>
+            <a:pPr algn="ctr">
+              <a:spcAft>
+                <a:spcPts val="600"/>
+              </a:spcAft>
+            </a:pPr>
+            <a:r>
+              <a:rPr sz="1300" b="1">
+                <a:solidFill>
+                  <a:srgbClr val="7B1A1A"/>
+                </a:solidFill>
+                <a:latin typeface="Calibri"/>
+              </a:rPr>
+              <a:t>(browser)</a:t>
+            </a:r>
+          </a:p>
+        </p:txBody>
+      </p:sp>
+      <p:sp>
+        <p:nvSpPr>
+          <p:cNvPr id="8" name="TextBox 7"/>
+          <p:cNvSpPr txBox="1"/>
+          <p:nvPr/>
+        </p:nvSpPr>
+        <p:spPr>
+          <a:xfrm>
+            <a:off x="2514600" y="2286000"/>
+            <a:ext cx="365760" cy="457200"/>
+          </a:xfrm>
+          <a:prstGeom prst="rect">
+            <a:avLst/>
+          </a:prstGeom>
+          <a:noFill/>
+        </p:spPr>
+        <p:txBody>
+          <a:bodyPr wrap="square" anchor="t">
+            <a:spAutoFit/>
+          </a:bodyPr>
+          <a:lstStyle/>
+          <a:p>
+            <a:pPr algn="l">
+              <a:spcAft>
+                <a:spcPts val="600"/>
+              </a:spcAft>
+            </a:pPr>
+            <a:r>
+              <a:rPr sz="2200" b="1">
+                <a:solidFill>
+                  <a:srgbClr val="C87A1E"/>
+                </a:solidFill>
+                <a:latin typeface="Calibri"/>
+              </a:rPr>
+              <a:t>&gt;</a:t>
+            </a:r>
+          </a:p>
+        </p:txBody>
+      </p:sp>
+      <p:sp>
+        <p:nvSpPr>
+          <p:cNvPr id="9" name="Rounded Rectangle 8"/>
+          <p:cNvSpPr/>
+          <p:nvPr/>
+        </p:nvSpPr>
+        <p:spPr>
+          <a:xfrm>
+            <a:off x="2743200" y="2011680"/>
+            <a:ext cx="2011680" cy="1188720"/>
+          </a:xfrm>
+          <a:prstGeom prst="roundRect">
+            <a:avLst/>
+          </a:prstGeom>
+          <a:solidFill>
+            <a:srgbClr val="FFFFFF"/>
+          </a:solidFill>
+          <a:ln w="12700">
+            <a:solidFill>
+              <a:srgbClr val="7B1A1A"/>
+            </a:solidFill>
+          </a:ln>
+          <a:effectLst/>
+        </p:spPr>
+        <p:style>
+          <a:lnRef idx="1">
+            <a:schemeClr val="accent1"/>
+          </a:lnRef>
+          <a:fillRef idx="3">
+            <a:schemeClr val="accent1"/>
+          </a:fillRef>
+          <a:effectRef idx="2">
+            <a:schemeClr val="accent1"/>
+          </a:effectRef>
+          <a:fontRef idx="minor">
+            <a:schemeClr val="lt1"/>
+          </a:fontRef>
+        </p:style>
+        <p:txBody>
+          <a:bodyPr rtlCol="0" anchor="ctr"/>
+          <a:lstStyle/>
+          <a:p>
+            <a:pPr algn="ctr"/>
+          </a:p>
+        </p:txBody>
+      </p:sp>
+      <p:sp>
+        <p:nvSpPr>
+          <p:cNvPr id="10" name="TextBox 9"/>
+          <p:cNvSpPr txBox="1"/>
+          <p:nvPr/>
+        </p:nvSpPr>
+        <p:spPr>
+          <a:xfrm>
+            <a:off x="2743200" y="2011680"/>
+            <a:ext cx="2011680" cy="1188720"/>
+          </a:xfrm>
+          <a:prstGeom prst="rect">
+            <a:avLst/>
+          </a:prstGeom>
+          <a:noFill/>
+        </p:spPr>
+        <p:txBody>
+          <a:bodyPr wrap="square" anchor="ctr">
+            <a:spAutoFit/>
+          </a:bodyPr>
+          <a:lstStyle/>
+          <a:p>
+            <a:pPr algn="ctr">
+              <a:spcAft>
+                <a:spcPts val="600"/>
+              </a:spcAft>
+            </a:pPr>
+            <a:r>
+              <a:rPr sz="1300" b="1">
+                <a:solidFill>
+                  <a:srgbClr val="7B1A1A"/>
+                </a:solidFill>
+                <a:latin typeface="Calibri"/>
+              </a:rPr>
+              <a:t>Nginx + TLS</a:t>
+            </a:r>
+          </a:p>
+          <a:p>
+            <a:pPr algn="ctr">
+              <a:spcAft>
+                <a:spcPts val="600"/>
+              </a:spcAft>
+            </a:pPr>
+            <a:r>
+              <a:rPr sz="1300" b="1">
+                <a:solidFill>
+                  <a:srgbClr val="7B1A1A"/>
+                </a:solidFill>
+                <a:latin typeface="Calibri"/>
+              </a:rPr>
+              <a:t>(Let's Encrypt)</a:t>
+            </a:r>
+          </a:p>
+        </p:txBody>
+      </p:sp>
+      <p:sp>
+        <p:nvSpPr>
+          <p:cNvPr id="11" name="TextBox 10"/>
+          <p:cNvSpPr txBox="1"/>
+          <p:nvPr/>
+        </p:nvSpPr>
+        <p:spPr>
+          <a:xfrm>
+            <a:off x="4709160" y="2286000"/>
+            <a:ext cx="365760" cy="457200"/>
+          </a:xfrm>
+          <a:prstGeom prst="rect">
+            <a:avLst/>
+          </a:prstGeom>
+          <a:noFill/>
+        </p:spPr>
+        <p:txBody>
+          <a:bodyPr wrap="square" anchor="t">
+            <a:spAutoFit/>
+          </a:bodyPr>
+          <a:lstStyle/>
+          <a:p>
+            <a:pPr algn="l">
+              <a:spcAft>
+                <a:spcPts val="600"/>
+              </a:spcAft>
+            </a:pPr>
+            <a:r>
+              <a:rPr sz="2200" b="1">
+                <a:solidFill>
+                  <a:srgbClr val="C87A1E"/>
+                </a:solidFill>
+                <a:latin typeface="Calibri"/>
+              </a:rPr>
+              <a:t>&gt;</a:t>
+            </a:r>
+          </a:p>
+        </p:txBody>
+      </p:sp>
+      <p:sp>
+        <p:nvSpPr>
+          <p:cNvPr id="12" name="Rounded Rectangle 11"/>
+          <p:cNvSpPr/>
+          <p:nvPr/>
+        </p:nvSpPr>
+        <p:spPr>
+          <a:xfrm>
+            <a:off x="4937760" y="2011680"/>
+            <a:ext cx="2011680" cy="1188720"/>
+          </a:xfrm>
+          <a:prstGeom prst="roundRect">
+            <a:avLst/>
+          </a:prstGeom>
+          <a:solidFill>
+            <a:srgbClr val="7B1A1A"/>
+          </a:solidFill>
+          <a:ln w="12700">
+            <a:solidFill>
+              <a:srgbClr val="7B1A1A"/>
+            </a:solidFill>
+          </a:ln>
+          <a:effectLst/>
+        </p:spPr>
+        <p:style>
+          <a:lnRef idx="1">
+            <a:schemeClr val="accent1"/>
+          </a:lnRef>
+          <a:fillRef idx="3">
+            <a:schemeClr val="accent1"/>
+          </a:fillRef>
+          <a:effectRef idx="2">
+            <a:schemeClr val="accent1"/>
+          </a:effectRef>
+          <a:fontRef idx="minor">
+            <a:schemeClr val="lt1"/>
+          </a:fontRef>
+        </p:style>
+        <p:txBody>
+          <a:bodyPr rtlCol="0" anchor="ctr"/>
+          <a:lstStyle/>
+          <a:p>
+            <a:pPr algn="ctr"/>
+          </a:p>
+        </p:txBody>
+      </p:sp>
+      <p:sp>
+        <p:nvSpPr>
+          <p:cNvPr id="13" name="TextBox 12"/>
+          <p:cNvSpPr txBox="1"/>
+          <p:nvPr/>
+        </p:nvSpPr>
+        <p:spPr>
+          <a:xfrm>
+            <a:off x="4937760" y="2011680"/>
+            <a:ext cx="2011680" cy="1188720"/>
+          </a:xfrm>
+          <a:prstGeom prst="rect">
+            <a:avLst/>
+          </a:prstGeom>
+          <a:noFill/>
+        </p:spPr>
+        <p:txBody>
+          <a:bodyPr wrap="square" anchor="ctr">
+            <a:spAutoFit/>
+          </a:bodyPr>
+          <a:lstStyle/>
+          <a:p>
+            <a:pPr algn="ctr">
+              <a:spcAft>
+                <a:spcPts val="600"/>
+              </a:spcAft>
+            </a:pPr>
+            <a:r>
+              <a:rPr sz="1300" b="1">
+                <a:solidFill>
+                  <a:srgbClr val="FFFFFF"/>
+                </a:solidFill>
+                <a:latin typeface="Calibri"/>
+              </a:rPr>
+              <a:t>Next.js 15 + React 19</a:t>
+            </a:r>
+          </a:p>
+          <a:p>
+            <a:pPr algn="ctr">
+              <a:spcAft>
+                <a:spcPts val="600"/>
+              </a:spcAft>
+            </a:pPr>
+            <a:r>
+              <a:rPr sz="1300" b="1">
+                <a:solidFill>
+                  <a:srgbClr val="FFFFFF"/>
+                </a:solidFill>
+                <a:latin typeface="Calibri"/>
+              </a:rPr>
+              <a:t>public site, admin UI</a:t>
+            </a:r>
+          </a:p>
+        </p:txBody>
+      </p:sp>
+      <p:sp>
+        <p:nvSpPr>
+          <p:cNvPr id="14" name="TextBox 13"/>
+          <p:cNvSpPr txBox="1"/>
+          <p:nvPr/>
+        </p:nvSpPr>
+        <p:spPr>
+          <a:xfrm>
+            <a:off x="6903720" y="2286000"/>
+            <a:ext cx="365760" cy="457200"/>
+          </a:xfrm>
+          <a:prstGeom prst="rect">
+            <a:avLst/>
+          </a:prstGeom>
+          <a:noFill/>
+        </p:spPr>
+        <p:txBody>
+          <a:bodyPr wrap="square" anchor="t">
+            <a:spAutoFit/>
+          </a:bodyPr>
+          <a:lstStyle/>
+          <a:p>
+            <a:pPr algn="l">
+              <a:spcAft>
+                <a:spcPts val="600"/>
+              </a:spcAft>
+            </a:pPr>
+            <a:r>
+              <a:rPr sz="2200" b="1">
+                <a:solidFill>
+                  <a:srgbClr val="C87A1E"/>
+                </a:solidFill>
+                <a:latin typeface="Calibri"/>
+              </a:rPr>
+              <a:t>&gt;</a:t>
+            </a:r>
+          </a:p>
+        </p:txBody>
+      </p:sp>
+      <p:sp>
+        <p:nvSpPr>
+          <p:cNvPr id="15" name="Rounded Rectangle 14"/>
+          <p:cNvSpPr/>
+          <p:nvPr/>
+        </p:nvSpPr>
+        <p:spPr>
+          <a:xfrm>
+            <a:off x="7315200" y="2011680"/>
+            <a:ext cx="2011680" cy="1188720"/>
+          </a:xfrm>
+          <a:prstGeom prst="roundRect">
+            <a:avLst/>
+          </a:prstGeom>
+          <a:solidFill>
+            <a:srgbClr val="7B1A1A"/>
+          </a:solidFill>
+          <a:ln w="12700">
+            <a:solidFill>
+              <a:srgbClr val="7B1A1A"/>
+            </a:solidFill>
+          </a:ln>
+          <a:effectLst/>
+        </p:spPr>
+        <p:style>
+          <a:lnRef idx="1">
+            <a:schemeClr val="accent1"/>
+          </a:lnRef>
+          <a:fillRef idx="3">
+            <a:schemeClr val="accent1"/>
+          </a:fillRef>
+          <a:effectRef idx="2">
+            <a:schemeClr val="accent1"/>
+          </a:effectRef>
+          <a:fontRef idx="minor">
+            <a:schemeClr val="lt1"/>
+          </a:fontRef>
+        </p:style>
+        <p:txBody>
+          <a:bodyPr rtlCol="0" anchor="ctr"/>
+          <a:lstStyle/>
+          <a:p>
+            <a:pPr algn="ctr"/>
+          </a:p>
+        </p:txBody>
+      </p:sp>
+      <p:sp>
+        <p:nvSpPr>
+          <p:cNvPr id="16" name="TextBox 15"/>
+          <p:cNvSpPr txBox="1"/>
+          <p:nvPr/>
+        </p:nvSpPr>
+        <p:spPr>
+          <a:xfrm>
+            <a:off x="7315200" y="2011680"/>
+            <a:ext cx="2011680" cy="1188720"/>
+          </a:xfrm>
+          <a:prstGeom prst="rect">
+            <a:avLst/>
+          </a:prstGeom>
+          <a:noFill/>
+        </p:spPr>
+        <p:txBody>
+          <a:bodyPr wrap="square" anchor="ctr">
+            <a:spAutoFit/>
+          </a:bodyPr>
+          <a:lstStyle/>
+          <a:p>
+            <a:pPr algn="ctr">
+              <a:spcAft>
+                <a:spcPts val="600"/>
+              </a:spcAft>
+            </a:pPr>
+            <a:r>
+              <a:rPr sz="1300" b="1">
+                <a:solidFill>
+                  <a:srgbClr val="FFFFFF"/>
+                </a:solidFill>
+                <a:latin typeface="Calibri"/>
+              </a:rPr>
+              <a:t>FastAPI (Python)</a:t>
+            </a:r>
+          </a:p>
+          <a:p>
+            <a:pPr algn="ctr">
+              <a:spcAft>
+                <a:spcPts val="600"/>
+              </a:spcAft>
+            </a:pPr>
+            <a:r>
+              <a:rPr sz="1300" b="1">
+                <a:solidFill>
+                  <a:srgbClr val="FFFFFF"/>
+                </a:solidFill>
+                <a:latin typeface="Calibri"/>
+              </a:rPr>
+              <a:t>52 REST endpoints, RBAC</a:t>
+            </a:r>
+          </a:p>
+        </p:txBody>
+      </p:sp>
+      <p:sp>
+        <p:nvSpPr>
+          <p:cNvPr id="17" name="TextBox 16"/>
+          <p:cNvSpPr txBox="1"/>
+          <p:nvPr/>
+        </p:nvSpPr>
+        <p:spPr>
+          <a:xfrm>
+            <a:off x="9281160" y="2286000"/>
+            <a:ext cx="365760" cy="457200"/>
+          </a:xfrm>
+          <a:prstGeom prst="rect">
+            <a:avLst/>
+          </a:prstGeom>
+          <a:noFill/>
+        </p:spPr>
+        <p:txBody>
+          <a:bodyPr wrap="square" anchor="t">
+            <a:spAutoFit/>
+          </a:bodyPr>
+          <a:lstStyle/>
+          <a:p>
+            <a:pPr algn="l">
+              <a:spcAft>
+                <a:spcPts val="600"/>
+              </a:spcAft>
+            </a:pPr>
+            <a:r>
+              <a:rPr sz="2200" b="1">
+                <a:solidFill>
+                  <a:srgbClr val="C87A1E"/>
+                </a:solidFill>
+                <a:latin typeface="Calibri"/>
+              </a:rPr>
+              <a:t>&gt;</a:t>
+            </a:r>
+          </a:p>
+        </p:txBody>
+      </p:sp>
+      <p:sp>
+        <p:nvSpPr>
+          <p:cNvPr id="18" name="Rounded Rectangle 17"/>
+          <p:cNvSpPr/>
+          <p:nvPr/>
+        </p:nvSpPr>
+        <p:spPr>
+          <a:xfrm>
+            <a:off x="9784080" y="2011680"/>
+            <a:ext cx="2011680" cy="1188720"/>
+          </a:xfrm>
+          <a:prstGeom prst="roundRect">
+            <a:avLst/>
+          </a:prstGeom>
+          <a:solidFill>
+            <a:srgbClr val="C87A1E"/>
+          </a:solidFill>
+          <a:ln w="12700">
+            <a:solidFill>
+              <a:srgbClr val="7B1A1A"/>
+            </a:solidFill>
+          </a:ln>
+          <a:effectLst/>
+        </p:spPr>
+        <p:style>
+          <a:lnRef idx="1">
+            <a:schemeClr val="accent1"/>
+          </a:lnRef>
+          <a:fillRef idx="3">
+            <a:schemeClr val="accent1"/>
+          </a:fillRef>
+          <a:effectRef idx="2">
+            <a:schemeClr val="accent1"/>
+          </a:effectRef>
+          <a:fontRef idx="minor">
+            <a:schemeClr val="lt1"/>
+          </a:fontRef>
+        </p:style>
+        <p:txBody>
+          <a:bodyPr rtlCol="0" anchor="ctr"/>
+          <a:lstStyle/>
+          <a:p>
+            <a:pPr algn="ctr"/>
+          </a:p>
+        </p:txBody>
+      </p:sp>
+      <p:sp>
+        <p:nvSpPr>
+          <p:cNvPr id="19" name="TextBox 18"/>
+          <p:cNvSpPr txBox="1"/>
+          <p:nvPr/>
+        </p:nvSpPr>
+        <p:spPr>
+          <a:xfrm>
+            <a:off x="9784080" y="2011680"/>
+            <a:ext cx="2011680" cy="1188720"/>
+          </a:xfrm>
+          <a:prstGeom prst="rect">
+            <a:avLst/>
+          </a:prstGeom>
+          <a:noFill/>
+        </p:spPr>
+        <p:txBody>
+          <a:bodyPr wrap="square" anchor="ctr">
+            <a:spAutoFit/>
+          </a:bodyPr>
+          <a:lstStyle/>
+          <a:p>
+            <a:pPr algn="ctr">
+              <a:spcAft>
+                <a:spcPts val="600"/>
+              </a:spcAft>
+            </a:pPr>
+            <a:r>
+              <a:rPr sz="1300" b="1">
+                <a:solidFill>
+                  <a:srgbClr val="FFFFFF"/>
+                </a:solidFill>
+                <a:latin typeface="Calibri"/>
+              </a:rPr>
+              <a:t>PostgreSQL</a:t>
+            </a:r>
+          </a:p>
+        </p:txBody>
+      </p:sp>
+      <p:sp>
+        <p:nvSpPr>
+          <p:cNvPr id="20" name="Rounded Rectangle 19"/>
+          <p:cNvSpPr/>
+          <p:nvPr/>
+        </p:nvSpPr>
+        <p:spPr>
+          <a:xfrm>
+            <a:off x="5760720" y="3931920"/>
+            <a:ext cx="2286000" cy="914400"/>
+          </a:xfrm>
+          <a:prstGeom prst="roundRect">
             <a:avLst/>
           </a:prstGeom>
           <a:solidFill>
@@ -3605,6 +4252,1638 @@
       </p:sp>
       <p:sp>
         <p:nvSpPr>
+          <p:cNvPr id="21" name="TextBox 20"/>
+          <p:cNvSpPr txBox="1"/>
+          <p:nvPr/>
+        </p:nvSpPr>
+        <p:spPr>
+          <a:xfrm>
+            <a:off x="5760720" y="3931920"/>
+            <a:ext cx="2286000" cy="914400"/>
+          </a:xfrm>
+          <a:prstGeom prst="rect">
+            <a:avLst/>
+          </a:prstGeom>
+          <a:noFill/>
+        </p:spPr>
+        <p:txBody>
+          <a:bodyPr wrap="square" anchor="ctr">
+            <a:spAutoFit/>
+          </a:bodyPr>
+          <a:lstStyle/>
+          <a:p>
+            <a:pPr algn="ctr">
+              <a:spcAft>
+                <a:spcPts val="600"/>
+              </a:spcAft>
+            </a:pPr>
+            <a:r>
+              <a:rPr sz="1200" b="1">
+                <a:solidFill>
+                  <a:srgbClr val="2B2020"/>
+                </a:solidFill>
+                <a:latin typeface="Calibri"/>
+              </a:rPr>
+              <a:t>AWS S3</a:t>
+            </a:r>
+          </a:p>
+          <a:p>
+            <a:pPr algn="ctr">
+              <a:spcAft>
+                <a:spcPts val="600"/>
+              </a:spcAft>
+            </a:pPr>
+            <a:r>
+              <a:rPr sz="1200" b="1">
+                <a:solidFill>
+                  <a:srgbClr val="2B2020"/>
+                </a:solidFill>
+                <a:latin typeface="Calibri"/>
+              </a:rPr>
+              <a:t>gallery, tickets, receipts</a:t>
+            </a:r>
+          </a:p>
+        </p:txBody>
+      </p:sp>
+      <p:sp>
+        <p:nvSpPr>
+          <p:cNvPr id="22" name="Rounded Rectangle 21"/>
+          <p:cNvSpPr/>
+          <p:nvPr/>
+        </p:nvSpPr>
+        <p:spPr>
+          <a:xfrm>
+            <a:off x="8229600" y="3931920"/>
+            <a:ext cx="2286000" cy="914400"/>
+          </a:xfrm>
+          <a:prstGeom prst="roundRect">
+            <a:avLst/>
+          </a:prstGeom>
+          <a:solidFill>
+            <a:srgbClr val="FFFFFF"/>
+          </a:solidFill>
+          <a:ln w="12700">
+            <a:solidFill>
+              <a:srgbClr val="C87A1E"/>
+            </a:solidFill>
+          </a:ln>
+          <a:effectLst/>
+        </p:spPr>
+        <p:style>
+          <a:lnRef idx="1">
+            <a:schemeClr val="accent1"/>
+          </a:lnRef>
+          <a:fillRef idx="3">
+            <a:schemeClr val="accent1"/>
+          </a:fillRef>
+          <a:effectRef idx="2">
+            <a:schemeClr val="accent1"/>
+          </a:effectRef>
+          <a:fontRef idx="minor">
+            <a:schemeClr val="lt1"/>
+          </a:fontRef>
+        </p:style>
+        <p:txBody>
+          <a:bodyPr rtlCol="0" anchor="ctr"/>
+          <a:lstStyle/>
+          <a:p>
+            <a:pPr algn="ctr"/>
+          </a:p>
+        </p:txBody>
+      </p:sp>
+      <p:sp>
+        <p:nvSpPr>
+          <p:cNvPr id="23" name="TextBox 22"/>
+          <p:cNvSpPr txBox="1"/>
+          <p:nvPr/>
+        </p:nvSpPr>
+        <p:spPr>
+          <a:xfrm>
+            <a:off x="8229600" y="3931920"/>
+            <a:ext cx="2286000" cy="914400"/>
+          </a:xfrm>
+          <a:prstGeom prst="rect">
+            <a:avLst/>
+          </a:prstGeom>
+          <a:noFill/>
+        </p:spPr>
+        <p:txBody>
+          <a:bodyPr wrap="square" anchor="ctr">
+            <a:spAutoFit/>
+          </a:bodyPr>
+          <a:lstStyle/>
+          <a:p>
+            <a:pPr algn="ctr">
+              <a:spcAft>
+                <a:spcPts val="600"/>
+              </a:spcAft>
+            </a:pPr>
+            <a:r>
+              <a:rPr sz="1200" b="1">
+                <a:solidFill>
+                  <a:srgbClr val="2B2020"/>
+                </a:solidFill>
+                <a:latin typeface="Calibri"/>
+              </a:rPr>
+              <a:t>AWS SES</a:t>
+            </a:r>
+          </a:p>
+          <a:p>
+            <a:pPr algn="ctr">
+              <a:spcAft>
+                <a:spcPts val="600"/>
+              </a:spcAft>
+            </a:pPr>
+            <a:r>
+              <a:rPr sz="1200" b="1">
+                <a:solidFill>
+                  <a:srgbClr val="2B2020"/>
+                </a:solidFill>
+                <a:latin typeface="Calibri"/>
+              </a:rPr>
+              <a:t>OTP, confirmations, alerts</a:t>
+            </a:r>
+          </a:p>
+        </p:txBody>
+      </p:sp>
+      <p:sp>
+        <p:nvSpPr>
+          <p:cNvPr id="24" name="TextBox 23"/>
+          <p:cNvSpPr txBox="1"/>
+          <p:nvPr/>
+        </p:nvSpPr>
+        <p:spPr>
+          <a:xfrm>
+            <a:off x="548640" y="3749039"/>
+            <a:ext cx="4937760" cy="2560320"/>
+          </a:xfrm>
+          <a:prstGeom prst="rect">
+            <a:avLst/>
+          </a:prstGeom>
+          <a:noFill/>
+        </p:spPr>
+        <p:txBody>
+          <a:bodyPr wrap="square" anchor="t">
+            <a:spAutoFit/>
+          </a:bodyPr>
+          <a:lstStyle/>
+          <a:p>
+            <a:pPr algn="l">
+              <a:spcAft>
+                <a:spcPts val="600"/>
+              </a:spcAft>
+            </a:pPr>
+            <a:r>
+              <a:rPr sz="1500" b="0">
+                <a:solidFill>
+                  <a:srgbClr val="2B2020"/>
+                </a:solidFill>
+                <a:latin typeface="Calibri"/>
+              </a:rPr>
+              <a:t>One server per temple: ~₹1,000 a month</a:t>
+            </a:r>
+          </a:p>
+          <a:p>
+            <a:pPr algn="l">
+              <a:spcAft>
+                <a:spcPts val="600"/>
+              </a:spcAft>
+            </a:pPr>
+            <a:r>
+              <a:rPr sz="1500" b="0">
+                <a:solidFill>
+                  <a:srgbClr val="2B2020"/>
+                </a:solidFill>
+                <a:latin typeface="Calibri"/>
+              </a:rPr>
+              <a:t>Docker Compose; GitHub Actions deploys after tests pass</a:t>
+            </a:r>
+          </a:p>
+          <a:p>
+            <a:pPr algn="l">
+              <a:spcAft>
+                <a:spcPts val="600"/>
+              </a:spcAft>
+            </a:pPr>
+            <a:r>
+              <a:rPr sz="1500" b="0">
+                <a:solidFill>
+                  <a:srgbClr val="2B2020"/>
+                </a:solidFill>
+                <a:latin typeface="Calibri"/>
+              </a:rPr>
+              <a:t>21 versioned DB migrations, ~40 test modules</a:t>
+            </a:r>
+          </a:p>
+          <a:p>
+            <a:pPr algn="l">
+              <a:spcAft>
+                <a:spcPts val="600"/>
+              </a:spcAft>
+            </a:pPr>
+            <a:r>
+              <a:rPr sz="1500" b="0">
+                <a:solidFill>
+                  <a:srgbClr val="2B2020"/>
+                </a:solidFill>
+                <a:latin typeface="Calibri"/>
+              </a:rPr>
+              <a:t>Each temple isolated: own domain, data and branding</a:t>
+            </a:r>
+          </a:p>
+        </p:txBody>
+      </p:sp>
+    </p:spTree>
+  </p:cSld>
+  <p:clrMapOvr>
+    <a:masterClrMapping/>
+  </p:clrMapOvr>
+</p:sld>
+</file>
+
+<file path=ppt/slides/slide11.xml><?xml version="1.0" encoding="utf-8"?>
+<p:sld xmlns:a="http://schemas.openxmlformats.org/drawingml/2006/main" xmlns:p="http://schemas.openxmlformats.org/presentationml/2006/main" xmlns:r="http://schemas.openxmlformats.org/officeDocument/2006/relationships">
+  <p:cSld>
+    <p:bg>
+      <p:bgPr>
+        <a:solidFill>
+          <a:srgbClr val="FAF5EA"/>
+        </a:solidFill>
+        <a:effectLst/>
+      </p:bgPr>
+    </p:bg>
+    <p:spTree>
+      <p:nvGrpSpPr>
+        <p:cNvPr id="1" name=""/>
+        <p:cNvGrpSpPr/>
+        <p:nvPr/>
+      </p:nvGrpSpPr>
+      <p:grpSpPr/>
+      <p:sp>
+        <p:nvSpPr>
+          <p:cNvPr id="2" name="Rectangle 1"/>
+          <p:cNvSpPr/>
+          <p:nvPr/>
+        </p:nvSpPr>
+        <p:spPr>
+          <a:xfrm>
+            <a:off x="0" y="0"/>
+            <a:ext cx="12191695" cy="109728"/>
+          </a:xfrm>
+          <a:prstGeom prst="rect">
+            <a:avLst/>
+          </a:prstGeom>
+          <a:solidFill>
+            <a:srgbClr val="C87A1E"/>
+          </a:solidFill>
+          <a:ln>
+            <a:noFill/>
+          </a:ln>
+          <a:effectLst/>
+        </p:spPr>
+        <p:style>
+          <a:lnRef idx="1">
+            <a:schemeClr val="accent1"/>
+          </a:lnRef>
+          <a:fillRef idx="3">
+            <a:schemeClr val="accent1"/>
+          </a:fillRef>
+          <a:effectRef idx="2">
+            <a:schemeClr val="accent1"/>
+          </a:effectRef>
+          <a:fontRef idx="minor">
+            <a:schemeClr val="lt1"/>
+          </a:fontRef>
+        </p:style>
+        <p:txBody>
+          <a:bodyPr rtlCol="0" anchor="ctr"/>
+          <a:lstStyle/>
+          <a:p>
+            <a:pPr algn="ctr"/>
+          </a:p>
+        </p:txBody>
+      </p:sp>
+      <p:sp>
+        <p:nvSpPr>
+          <p:cNvPr id="3" name="TextBox 2"/>
+          <p:cNvSpPr txBox="1"/>
+          <p:nvPr/>
+        </p:nvSpPr>
+        <p:spPr>
+          <a:xfrm>
+            <a:off x="548640" y="320040"/>
+            <a:ext cx="10972800" cy="822960"/>
+          </a:xfrm>
+          <a:prstGeom prst="rect">
+            <a:avLst/>
+          </a:prstGeom>
+          <a:noFill/>
+        </p:spPr>
+        <p:txBody>
+          <a:bodyPr wrap="square" anchor="t">
+            <a:spAutoFit/>
+          </a:bodyPr>
+          <a:lstStyle/>
+          <a:p>
+            <a:pPr algn="l">
+              <a:spcAft>
+                <a:spcPts val="600"/>
+              </a:spcAft>
+            </a:pPr>
+            <a:r>
+              <a:rPr sz="3200" b="1">
+                <a:solidFill>
+                  <a:srgbClr val="7B1A1A"/>
+                </a:solidFill>
+                <a:latin typeface="Georgia"/>
+              </a:rPr>
+              <a:t>Trust: security and privacy built in</a:t>
+            </a:r>
+          </a:p>
+        </p:txBody>
+      </p:sp>
+      <p:sp>
+        <p:nvSpPr>
+          <p:cNvPr id="4" name="TextBox 3"/>
+          <p:cNvSpPr txBox="1"/>
+          <p:nvPr/>
+        </p:nvSpPr>
+        <p:spPr>
+          <a:xfrm>
+            <a:off x="548640" y="6446520"/>
+            <a:ext cx="7315200" cy="274320"/>
+          </a:xfrm>
+          <a:prstGeom prst="rect">
+            <a:avLst/>
+          </a:prstGeom>
+          <a:noFill/>
+        </p:spPr>
+        <p:txBody>
+          <a:bodyPr wrap="square" anchor="t">
+            <a:spAutoFit/>
+          </a:bodyPr>
+          <a:lstStyle/>
+          <a:p>
+            <a:pPr algn="l">
+              <a:spcAft>
+                <a:spcPts val="600"/>
+              </a:spcAft>
+            </a:pPr>
+            <a:r>
+              <a:rPr sz="1000" b="0">
+                <a:solidFill>
+                  <a:srgbClr val="887777"/>
+                </a:solidFill>
+                <a:latin typeface="Calibri"/>
+              </a:rPr>
+              <a:t>Temple Platform  |  Vriksha Studio</a:t>
+            </a:r>
+          </a:p>
+        </p:txBody>
+      </p:sp>
+      <p:sp>
+        <p:nvSpPr>
+          <p:cNvPr id="5" name="Rectangle 4"/>
+          <p:cNvSpPr/>
+          <p:nvPr/>
+        </p:nvSpPr>
+        <p:spPr>
+          <a:xfrm>
+            <a:off x="548640" y="1463040"/>
+            <a:ext cx="3611880" cy="2194560"/>
+          </a:xfrm>
+          <a:prstGeom prst="rect">
+            <a:avLst/>
+          </a:prstGeom>
+          <a:solidFill>
+            <a:srgbClr val="FFFFFF"/>
+          </a:solidFill>
+          <a:ln w="12700">
+            <a:solidFill>
+              <a:srgbClr val="E6D9C3"/>
+            </a:solidFill>
+          </a:ln>
+          <a:effectLst/>
+        </p:spPr>
+        <p:style>
+          <a:lnRef idx="1">
+            <a:schemeClr val="accent1"/>
+          </a:lnRef>
+          <a:fillRef idx="3">
+            <a:schemeClr val="accent1"/>
+          </a:fillRef>
+          <a:effectRef idx="2">
+            <a:schemeClr val="accent1"/>
+          </a:effectRef>
+          <a:fontRef idx="minor">
+            <a:schemeClr val="lt1"/>
+          </a:fontRef>
+        </p:style>
+        <p:txBody>
+          <a:bodyPr rtlCol="0" anchor="ctr"/>
+          <a:lstStyle/>
+          <a:p>
+            <a:pPr algn="ctr"/>
+          </a:p>
+        </p:txBody>
+      </p:sp>
+      <p:sp>
+        <p:nvSpPr>
+          <p:cNvPr id="6" name="Rectangle 5"/>
+          <p:cNvSpPr/>
+          <p:nvPr/>
+        </p:nvSpPr>
+        <p:spPr>
+          <a:xfrm>
+            <a:off x="548640" y="1463040"/>
+            <a:ext cx="3611880" cy="91440"/>
+          </a:xfrm>
+          <a:prstGeom prst="rect">
+            <a:avLst/>
+          </a:prstGeom>
+          <a:solidFill>
+            <a:srgbClr val="7B1A1A"/>
+          </a:solidFill>
+          <a:ln>
+            <a:noFill/>
+          </a:ln>
+          <a:effectLst/>
+        </p:spPr>
+        <p:style>
+          <a:lnRef idx="1">
+            <a:schemeClr val="accent1"/>
+          </a:lnRef>
+          <a:fillRef idx="3">
+            <a:schemeClr val="accent1"/>
+          </a:fillRef>
+          <a:effectRef idx="2">
+            <a:schemeClr val="accent1"/>
+          </a:effectRef>
+          <a:fontRef idx="minor">
+            <a:schemeClr val="lt1"/>
+          </a:fontRef>
+        </p:style>
+        <p:txBody>
+          <a:bodyPr rtlCol="0" anchor="ctr"/>
+          <a:lstStyle/>
+          <a:p>
+            <a:pPr algn="ctr"/>
+          </a:p>
+        </p:txBody>
+      </p:sp>
+      <p:sp>
+        <p:nvSpPr>
+          <p:cNvPr id="7" name="TextBox 6"/>
+          <p:cNvSpPr txBox="1"/>
+          <p:nvPr/>
+        </p:nvSpPr>
+        <p:spPr>
+          <a:xfrm>
+            <a:off x="731520" y="1645920"/>
+            <a:ext cx="3246120" cy="457200"/>
+          </a:xfrm>
+          <a:prstGeom prst="rect">
+            <a:avLst/>
+          </a:prstGeom>
+          <a:noFill/>
+        </p:spPr>
+        <p:txBody>
+          <a:bodyPr wrap="square" anchor="t">
+            <a:spAutoFit/>
+          </a:bodyPr>
+          <a:lstStyle/>
+          <a:p>
+            <a:pPr algn="l">
+              <a:spcAft>
+                <a:spcPts val="600"/>
+              </a:spcAft>
+            </a:pPr>
+            <a:r>
+              <a:rPr sz="1800" b="1">
+                <a:solidFill>
+                  <a:srgbClr val="7B1A1A"/>
+                </a:solidFill>
+                <a:latin typeface="Georgia"/>
+              </a:rPr>
+              <a:t>Access control</a:t>
+            </a:r>
+          </a:p>
+        </p:txBody>
+      </p:sp>
+      <p:sp>
+        <p:nvSpPr>
+          <p:cNvPr id="8" name="TextBox 7"/>
+          <p:cNvSpPr txBox="1"/>
+          <p:nvPr/>
+        </p:nvSpPr>
+        <p:spPr>
+          <a:xfrm>
+            <a:off x="731520" y="2148840"/>
+            <a:ext cx="3246120" cy="1371600"/>
+          </a:xfrm>
+          <a:prstGeom prst="rect">
+            <a:avLst/>
+          </a:prstGeom>
+          <a:noFill/>
+        </p:spPr>
+        <p:txBody>
+          <a:bodyPr wrap="square" anchor="t">
+            <a:spAutoFit/>
+          </a:bodyPr>
+          <a:lstStyle/>
+          <a:p>
+            <a:pPr algn="l">
+              <a:spcAft>
+                <a:spcPts val="600"/>
+              </a:spcAft>
+            </a:pPr>
+            <a:r>
+              <a:rPr sz="1400" b="0">
+                <a:solidFill>
+                  <a:srgbClr val="2B2020"/>
+                </a:solidFill>
+                <a:latin typeface="Calibri"/>
+              </a:rPr>
+              <a:t>Five roles; permissions checked on the server for every action</a:t>
+            </a:r>
+          </a:p>
+        </p:txBody>
+      </p:sp>
+      <p:sp>
+        <p:nvSpPr>
+          <p:cNvPr id="9" name="Rectangle 8"/>
+          <p:cNvSpPr/>
+          <p:nvPr/>
+        </p:nvSpPr>
+        <p:spPr>
+          <a:xfrm>
+            <a:off x="4343400" y="1463040"/>
+            <a:ext cx="3611880" cy="2194560"/>
+          </a:xfrm>
+          <a:prstGeom prst="rect">
+            <a:avLst/>
+          </a:prstGeom>
+          <a:solidFill>
+            <a:srgbClr val="FFFFFF"/>
+          </a:solidFill>
+          <a:ln w="12700">
+            <a:solidFill>
+              <a:srgbClr val="E6D9C3"/>
+            </a:solidFill>
+          </a:ln>
+          <a:effectLst/>
+        </p:spPr>
+        <p:style>
+          <a:lnRef idx="1">
+            <a:schemeClr val="accent1"/>
+          </a:lnRef>
+          <a:fillRef idx="3">
+            <a:schemeClr val="accent1"/>
+          </a:fillRef>
+          <a:effectRef idx="2">
+            <a:schemeClr val="accent1"/>
+          </a:effectRef>
+          <a:fontRef idx="minor">
+            <a:schemeClr val="lt1"/>
+          </a:fontRef>
+        </p:style>
+        <p:txBody>
+          <a:bodyPr rtlCol="0" anchor="ctr"/>
+          <a:lstStyle/>
+          <a:p>
+            <a:pPr algn="ctr"/>
+          </a:p>
+        </p:txBody>
+      </p:sp>
+      <p:sp>
+        <p:nvSpPr>
+          <p:cNvPr id="10" name="Rectangle 9"/>
+          <p:cNvSpPr/>
+          <p:nvPr/>
+        </p:nvSpPr>
+        <p:spPr>
+          <a:xfrm>
+            <a:off x="4343400" y="1463040"/>
+            <a:ext cx="3611880" cy="91440"/>
+          </a:xfrm>
+          <a:prstGeom prst="rect">
+            <a:avLst/>
+          </a:prstGeom>
+          <a:solidFill>
+            <a:srgbClr val="C87A1E"/>
+          </a:solidFill>
+          <a:ln>
+            <a:noFill/>
+          </a:ln>
+          <a:effectLst/>
+        </p:spPr>
+        <p:style>
+          <a:lnRef idx="1">
+            <a:schemeClr val="accent1"/>
+          </a:lnRef>
+          <a:fillRef idx="3">
+            <a:schemeClr val="accent1"/>
+          </a:fillRef>
+          <a:effectRef idx="2">
+            <a:schemeClr val="accent1"/>
+          </a:effectRef>
+          <a:fontRef idx="minor">
+            <a:schemeClr val="lt1"/>
+          </a:fontRef>
+        </p:style>
+        <p:txBody>
+          <a:bodyPr rtlCol="0" anchor="ctr"/>
+          <a:lstStyle/>
+          <a:p>
+            <a:pPr algn="ctr"/>
+          </a:p>
+        </p:txBody>
+      </p:sp>
+      <p:sp>
+        <p:nvSpPr>
+          <p:cNvPr id="11" name="TextBox 10"/>
+          <p:cNvSpPr txBox="1"/>
+          <p:nvPr/>
+        </p:nvSpPr>
+        <p:spPr>
+          <a:xfrm>
+            <a:off x="4526280" y="1645920"/>
+            <a:ext cx="3246120" cy="457200"/>
+          </a:xfrm>
+          <a:prstGeom prst="rect">
+            <a:avLst/>
+          </a:prstGeom>
+          <a:noFill/>
+        </p:spPr>
+        <p:txBody>
+          <a:bodyPr wrap="square" anchor="t">
+            <a:spAutoFit/>
+          </a:bodyPr>
+          <a:lstStyle/>
+          <a:p>
+            <a:pPr algn="l">
+              <a:spcAft>
+                <a:spcPts val="600"/>
+              </a:spcAft>
+            </a:pPr>
+            <a:r>
+              <a:rPr sz="1800" b="1">
+                <a:solidFill>
+                  <a:srgbClr val="C87A1E"/>
+                </a:solidFill>
+                <a:latin typeface="Georgia"/>
+              </a:rPr>
+              <a:t>Two-factor login</a:t>
+            </a:r>
+          </a:p>
+        </p:txBody>
+      </p:sp>
+      <p:sp>
+        <p:nvSpPr>
+          <p:cNvPr id="12" name="TextBox 11"/>
+          <p:cNvSpPr txBox="1"/>
+          <p:nvPr/>
+        </p:nvSpPr>
+        <p:spPr>
+          <a:xfrm>
+            <a:off x="4526280" y="2148840"/>
+            <a:ext cx="3246120" cy="1371600"/>
+          </a:xfrm>
+          <a:prstGeom prst="rect">
+            <a:avLst/>
+          </a:prstGeom>
+          <a:noFill/>
+        </p:spPr>
+        <p:txBody>
+          <a:bodyPr wrap="square" anchor="t">
+            <a:spAutoFit/>
+          </a:bodyPr>
+          <a:lstStyle/>
+          <a:p>
+            <a:pPr algn="l">
+              <a:spcAft>
+                <a:spcPts val="600"/>
+              </a:spcAft>
+            </a:pPr>
+            <a:r>
+              <a:rPr sz="1400" b="0">
+                <a:solidFill>
+                  <a:srgbClr val="2B2020"/>
+                </a:solidFill>
+                <a:latin typeface="Calibri"/>
+              </a:rPr>
+              <a:t>Email OTP; 30-minute idle timeout</a:t>
+            </a:r>
+          </a:p>
+        </p:txBody>
+      </p:sp>
+      <p:sp>
+        <p:nvSpPr>
+          <p:cNvPr id="13" name="Rectangle 12"/>
+          <p:cNvSpPr/>
+          <p:nvPr/>
+        </p:nvSpPr>
+        <p:spPr>
+          <a:xfrm>
+            <a:off x="8138160" y="1463040"/>
+            <a:ext cx="3611880" cy="2194560"/>
+          </a:xfrm>
+          <a:prstGeom prst="rect">
+            <a:avLst/>
+          </a:prstGeom>
+          <a:solidFill>
+            <a:srgbClr val="FFFFFF"/>
+          </a:solidFill>
+          <a:ln w="12700">
+            <a:solidFill>
+              <a:srgbClr val="E6D9C3"/>
+            </a:solidFill>
+          </a:ln>
+          <a:effectLst/>
+        </p:spPr>
+        <p:style>
+          <a:lnRef idx="1">
+            <a:schemeClr val="accent1"/>
+          </a:lnRef>
+          <a:fillRef idx="3">
+            <a:schemeClr val="accent1"/>
+          </a:fillRef>
+          <a:effectRef idx="2">
+            <a:schemeClr val="accent1"/>
+          </a:effectRef>
+          <a:fontRef idx="minor">
+            <a:schemeClr val="lt1"/>
+          </a:fontRef>
+        </p:style>
+        <p:txBody>
+          <a:bodyPr rtlCol="0" anchor="ctr"/>
+          <a:lstStyle/>
+          <a:p>
+            <a:pPr algn="ctr"/>
+          </a:p>
+        </p:txBody>
+      </p:sp>
+      <p:sp>
+        <p:nvSpPr>
+          <p:cNvPr id="14" name="Rectangle 13"/>
+          <p:cNvSpPr/>
+          <p:nvPr/>
+        </p:nvSpPr>
+        <p:spPr>
+          <a:xfrm>
+            <a:off x="8138160" y="1463040"/>
+            <a:ext cx="3611880" cy="91440"/>
+          </a:xfrm>
+          <a:prstGeom prst="rect">
+            <a:avLst/>
+          </a:prstGeom>
+          <a:solidFill>
+            <a:srgbClr val="7B1A1A"/>
+          </a:solidFill>
+          <a:ln>
+            <a:noFill/>
+          </a:ln>
+          <a:effectLst/>
+        </p:spPr>
+        <p:style>
+          <a:lnRef idx="1">
+            <a:schemeClr val="accent1"/>
+          </a:lnRef>
+          <a:fillRef idx="3">
+            <a:schemeClr val="accent1"/>
+          </a:fillRef>
+          <a:effectRef idx="2">
+            <a:schemeClr val="accent1"/>
+          </a:effectRef>
+          <a:fontRef idx="minor">
+            <a:schemeClr val="lt1"/>
+          </a:fontRef>
+        </p:style>
+        <p:txBody>
+          <a:bodyPr rtlCol="0" anchor="ctr"/>
+          <a:lstStyle/>
+          <a:p>
+            <a:pPr algn="ctr"/>
+          </a:p>
+        </p:txBody>
+      </p:sp>
+      <p:sp>
+        <p:nvSpPr>
+          <p:cNvPr id="15" name="TextBox 14"/>
+          <p:cNvSpPr txBox="1"/>
+          <p:nvPr/>
+        </p:nvSpPr>
+        <p:spPr>
+          <a:xfrm>
+            <a:off x="8321040" y="1645920"/>
+            <a:ext cx="3246120" cy="457200"/>
+          </a:xfrm>
+          <a:prstGeom prst="rect">
+            <a:avLst/>
+          </a:prstGeom>
+          <a:noFill/>
+        </p:spPr>
+        <p:txBody>
+          <a:bodyPr wrap="square" anchor="t">
+            <a:spAutoFit/>
+          </a:bodyPr>
+          <a:lstStyle/>
+          <a:p>
+            <a:pPr algn="l">
+              <a:spcAft>
+                <a:spcPts val="600"/>
+              </a:spcAft>
+            </a:pPr>
+            <a:r>
+              <a:rPr sz="1800" b="1">
+                <a:solidFill>
+                  <a:srgbClr val="7B1A1A"/>
+                </a:solidFill>
+                <a:latin typeface="Georgia"/>
+              </a:rPr>
+              <a:t>Audit trail</a:t>
+            </a:r>
+          </a:p>
+        </p:txBody>
+      </p:sp>
+      <p:sp>
+        <p:nvSpPr>
+          <p:cNvPr id="16" name="TextBox 15"/>
+          <p:cNvSpPr txBox="1"/>
+          <p:nvPr/>
+        </p:nvSpPr>
+        <p:spPr>
+          <a:xfrm>
+            <a:off x="8321040" y="2148840"/>
+            <a:ext cx="3246120" cy="1371600"/>
+          </a:xfrm>
+          <a:prstGeom prst="rect">
+            <a:avLst/>
+          </a:prstGeom>
+          <a:noFill/>
+        </p:spPr>
+        <p:txBody>
+          <a:bodyPr wrap="square" anchor="t">
+            <a:spAutoFit/>
+          </a:bodyPr>
+          <a:lstStyle/>
+          <a:p>
+            <a:pPr algn="l">
+              <a:spcAft>
+                <a:spcPts val="600"/>
+              </a:spcAft>
+            </a:pPr>
+            <a:r>
+              <a:rPr sz="1400" b="0">
+                <a:solidFill>
+                  <a:srgbClr val="2B2020"/>
+                </a:solidFill>
+                <a:latin typeface="Calibri"/>
+              </a:rPr>
+              <a:t>Every change recorded; alerts on bulk deletions</a:t>
+            </a:r>
+          </a:p>
+        </p:txBody>
+      </p:sp>
+      <p:sp>
+        <p:nvSpPr>
+          <p:cNvPr id="17" name="Rectangle 16"/>
+          <p:cNvSpPr/>
+          <p:nvPr/>
+        </p:nvSpPr>
+        <p:spPr>
+          <a:xfrm>
+            <a:off x="548640" y="3931920"/>
+            <a:ext cx="3611880" cy="2194560"/>
+          </a:xfrm>
+          <a:prstGeom prst="rect">
+            <a:avLst/>
+          </a:prstGeom>
+          <a:solidFill>
+            <a:srgbClr val="FFFFFF"/>
+          </a:solidFill>
+          <a:ln w="12700">
+            <a:solidFill>
+              <a:srgbClr val="E6D9C3"/>
+            </a:solidFill>
+          </a:ln>
+          <a:effectLst/>
+        </p:spPr>
+        <p:style>
+          <a:lnRef idx="1">
+            <a:schemeClr val="accent1"/>
+          </a:lnRef>
+          <a:fillRef idx="3">
+            <a:schemeClr val="accent1"/>
+          </a:fillRef>
+          <a:effectRef idx="2">
+            <a:schemeClr val="accent1"/>
+          </a:effectRef>
+          <a:fontRef idx="minor">
+            <a:schemeClr val="lt1"/>
+          </a:fontRef>
+        </p:style>
+        <p:txBody>
+          <a:bodyPr rtlCol="0" anchor="ctr"/>
+          <a:lstStyle/>
+          <a:p>
+            <a:pPr algn="ctr"/>
+          </a:p>
+        </p:txBody>
+      </p:sp>
+      <p:sp>
+        <p:nvSpPr>
+          <p:cNvPr id="18" name="Rectangle 17"/>
+          <p:cNvSpPr/>
+          <p:nvPr/>
+        </p:nvSpPr>
+        <p:spPr>
+          <a:xfrm>
+            <a:off x="548640" y="3931920"/>
+            <a:ext cx="3611880" cy="91440"/>
+          </a:xfrm>
+          <a:prstGeom prst="rect">
+            <a:avLst/>
+          </a:prstGeom>
+          <a:solidFill>
+            <a:srgbClr val="C87A1E"/>
+          </a:solidFill>
+          <a:ln>
+            <a:noFill/>
+          </a:ln>
+          <a:effectLst/>
+        </p:spPr>
+        <p:style>
+          <a:lnRef idx="1">
+            <a:schemeClr val="accent1"/>
+          </a:lnRef>
+          <a:fillRef idx="3">
+            <a:schemeClr val="accent1"/>
+          </a:fillRef>
+          <a:effectRef idx="2">
+            <a:schemeClr val="accent1"/>
+          </a:effectRef>
+          <a:fontRef idx="minor">
+            <a:schemeClr val="lt1"/>
+          </a:fontRef>
+        </p:style>
+        <p:txBody>
+          <a:bodyPr rtlCol="0" anchor="ctr"/>
+          <a:lstStyle/>
+          <a:p>
+            <a:pPr algn="ctr"/>
+          </a:p>
+        </p:txBody>
+      </p:sp>
+      <p:sp>
+        <p:nvSpPr>
+          <p:cNvPr id="19" name="TextBox 18"/>
+          <p:cNvSpPr txBox="1"/>
+          <p:nvPr/>
+        </p:nvSpPr>
+        <p:spPr>
+          <a:xfrm>
+            <a:off x="731520" y="4114800"/>
+            <a:ext cx="3246120" cy="457200"/>
+          </a:xfrm>
+          <a:prstGeom prst="rect">
+            <a:avLst/>
+          </a:prstGeom>
+          <a:noFill/>
+        </p:spPr>
+        <p:txBody>
+          <a:bodyPr wrap="square" anchor="t">
+            <a:spAutoFit/>
+          </a:bodyPr>
+          <a:lstStyle/>
+          <a:p>
+            <a:pPr algn="l">
+              <a:spcAft>
+                <a:spcPts val="600"/>
+              </a:spcAft>
+            </a:pPr>
+            <a:r>
+              <a:rPr sz="1800" b="1">
+                <a:solidFill>
+                  <a:srgbClr val="C87A1E"/>
+                </a:solidFill>
+                <a:latin typeface="Georgia"/>
+              </a:rPr>
+              <a:t>Abuse protection</a:t>
+            </a:r>
+          </a:p>
+        </p:txBody>
+      </p:sp>
+      <p:sp>
+        <p:nvSpPr>
+          <p:cNvPr id="20" name="TextBox 19"/>
+          <p:cNvSpPr txBox="1"/>
+          <p:nvPr/>
+        </p:nvSpPr>
+        <p:spPr>
+          <a:xfrm>
+            <a:off x="731520" y="4617720"/>
+            <a:ext cx="3246120" cy="1371600"/>
+          </a:xfrm>
+          <a:prstGeom prst="rect">
+            <a:avLst/>
+          </a:prstGeom>
+          <a:noFill/>
+        </p:spPr>
+        <p:txBody>
+          <a:bodyPr wrap="square" anchor="t">
+            <a:spAutoFit/>
+          </a:bodyPr>
+          <a:lstStyle/>
+          <a:p>
+            <a:pPr algn="l">
+              <a:spcAft>
+                <a:spcPts val="600"/>
+              </a:spcAft>
+            </a:pPr>
+            <a:r>
+              <a:rPr sz="1400" b="0">
+                <a:solidFill>
+                  <a:srgbClr val="2B2020"/>
+                </a:solidFill>
+                <a:latin typeface="Calibri"/>
+              </a:rPr>
+              <a:t>Rate limiting and bot challenge on public forms</a:t>
+            </a:r>
+          </a:p>
+        </p:txBody>
+      </p:sp>
+      <p:sp>
+        <p:nvSpPr>
+          <p:cNvPr id="21" name="Rectangle 20"/>
+          <p:cNvSpPr/>
+          <p:nvPr/>
+        </p:nvSpPr>
+        <p:spPr>
+          <a:xfrm>
+            <a:off x="4343400" y="3931920"/>
+            <a:ext cx="3611880" cy="2194560"/>
+          </a:xfrm>
+          <a:prstGeom prst="rect">
+            <a:avLst/>
+          </a:prstGeom>
+          <a:solidFill>
+            <a:srgbClr val="FFFFFF"/>
+          </a:solidFill>
+          <a:ln w="12700">
+            <a:solidFill>
+              <a:srgbClr val="E6D9C3"/>
+            </a:solidFill>
+          </a:ln>
+          <a:effectLst/>
+        </p:spPr>
+        <p:style>
+          <a:lnRef idx="1">
+            <a:schemeClr val="accent1"/>
+          </a:lnRef>
+          <a:fillRef idx="3">
+            <a:schemeClr val="accent1"/>
+          </a:fillRef>
+          <a:effectRef idx="2">
+            <a:schemeClr val="accent1"/>
+          </a:effectRef>
+          <a:fontRef idx="minor">
+            <a:schemeClr val="lt1"/>
+          </a:fontRef>
+        </p:style>
+        <p:txBody>
+          <a:bodyPr rtlCol="0" anchor="ctr"/>
+          <a:lstStyle/>
+          <a:p>
+            <a:pPr algn="ctr"/>
+          </a:p>
+        </p:txBody>
+      </p:sp>
+      <p:sp>
+        <p:nvSpPr>
+          <p:cNvPr id="22" name="Rectangle 21"/>
+          <p:cNvSpPr/>
+          <p:nvPr/>
+        </p:nvSpPr>
+        <p:spPr>
+          <a:xfrm>
+            <a:off x="4343400" y="3931920"/>
+            <a:ext cx="3611880" cy="91440"/>
+          </a:xfrm>
+          <a:prstGeom prst="rect">
+            <a:avLst/>
+          </a:prstGeom>
+          <a:solidFill>
+            <a:srgbClr val="7B1A1A"/>
+          </a:solidFill>
+          <a:ln>
+            <a:noFill/>
+          </a:ln>
+          <a:effectLst/>
+        </p:spPr>
+        <p:style>
+          <a:lnRef idx="1">
+            <a:schemeClr val="accent1"/>
+          </a:lnRef>
+          <a:fillRef idx="3">
+            <a:schemeClr val="accent1"/>
+          </a:fillRef>
+          <a:effectRef idx="2">
+            <a:schemeClr val="accent1"/>
+          </a:effectRef>
+          <a:fontRef idx="minor">
+            <a:schemeClr val="lt1"/>
+          </a:fontRef>
+        </p:style>
+        <p:txBody>
+          <a:bodyPr rtlCol="0" anchor="ctr"/>
+          <a:lstStyle/>
+          <a:p>
+            <a:pPr algn="ctr"/>
+          </a:p>
+        </p:txBody>
+      </p:sp>
+      <p:sp>
+        <p:nvSpPr>
+          <p:cNvPr id="23" name="TextBox 22"/>
+          <p:cNvSpPr txBox="1"/>
+          <p:nvPr/>
+        </p:nvSpPr>
+        <p:spPr>
+          <a:xfrm>
+            <a:off x="4526280" y="4114800"/>
+            <a:ext cx="3246120" cy="457200"/>
+          </a:xfrm>
+          <a:prstGeom prst="rect">
+            <a:avLst/>
+          </a:prstGeom>
+          <a:noFill/>
+        </p:spPr>
+        <p:txBody>
+          <a:bodyPr wrap="square" anchor="t">
+            <a:spAutoFit/>
+          </a:bodyPr>
+          <a:lstStyle/>
+          <a:p>
+            <a:pPr algn="l">
+              <a:spcAft>
+                <a:spcPts val="600"/>
+              </a:spcAft>
+            </a:pPr>
+            <a:r>
+              <a:rPr sz="1800" b="1">
+                <a:solidFill>
+                  <a:srgbClr val="7B1A1A"/>
+                </a:solidFill>
+                <a:latin typeface="Georgia"/>
+              </a:rPr>
+              <a:t>Privacy (DPDPA)</a:t>
+            </a:r>
+          </a:p>
+        </p:txBody>
+      </p:sp>
+      <p:sp>
+        <p:nvSpPr>
+          <p:cNvPr id="24" name="TextBox 23"/>
+          <p:cNvSpPr txBox="1"/>
+          <p:nvPr/>
+        </p:nvSpPr>
+        <p:spPr>
+          <a:xfrm>
+            <a:off x="4526280" y="4617720"/>
+            <a:ext cx="3246120" cy="1371600"/>
+          </a:xfrm>
+          <a:prstGeom prst="rect">
+            <a:avLst/>
+          </a:prstGeom>
+          <a:noFill/>
+        </p:spPr>
+        <p:txBody>
+          <a:bodyPr wrap="square" anchor="t">
+            <a:spAutoFit/>
+          </a:bodyPr>
+          <a:lstStyle/>
+          <a:p>
+            <a:pPr algn="l">
+              <a:spcAft>
+                <a:spcPts val="600"/>
+              </a:spcAft>
+            </a:pPr>
+            <a:r>
+              <a:rPr sz="1400" b="0">
+                <a:solidFill>
+                  <a:srgbClr val="2B2020"/>
+                </a:solidFill>
+                <a:latin typeface="Calibri"/>
+              </a:rPr>
+              <a:t>Privacy policy on site, emails and tickets</a:t>
+            </a:r>
+          </a:p>
+        </p:txBody>
+      </p:sp>
+      <p:sp>
+        <p:nvSpPr>
+          <p:cNvPr id="25" name="Rectangle 24"/>
+          <p:cNvSpPr/>
+          <p:nvPr/>
+        </p:nvSpPr>
+        <p:spPr>
+          <a:xfrm>
+            <a:off x="8138160" y="3931920"/>
+            <a:ext cx="3611880" cy="2194560"/>
+          </a:xfrm>
+          <a:prstGeom prst="rect">
+            <a:avLst/>
+          </a:prstGeom>
+          <a:solidFill>
+            <a:srgbClr val="FFFFFF"/>
+          </a:solidFill>
+          <a:ln w="12700">
+            <a:solidFill>
+              <a:srgbClr val="E6D9C3"/>
+            </a:solidFill>
+          </a:ln>
+          <a:effectLst/>
+        </p:spPr>
+        <p:style>
+          <a:lnRef idx="1">
+            <a:schemeClr val="accent1"/>
+          </a:lnRef>
+          <a:fillRef idx="3">
+            <a:schemeClr val="accent1"/>
+          </a:fillRef>
+          <a:effectRef idx="2">
+            <a:schemeClr val="accent1"/>
+          </a:effectRef>
+          <a:fontRef idx="minor">
+            <a:schemeClr val="lt1"/>
+          </a:fontRef>
+        </p:style>
+        <p:txBody>
+          <a:bodyPr rtlCol="0" anchor="ctr"/>
+          <a:lstStyle/>
+          <a:p>
+            <a:pPr algn="ctr"/>
+          </a:p>
+        </p:txBody>
+      </p:sp>
+      <p:sp>
+        <p:nvSpPr>
+          <p:cNvPr id="26" name="Rectangle 25"/>
+          <p:cNvSpPr/>
+          <p:nvPr/>
+        </p:nvSpPr>
+        <p:spPr>
+          <a:xfrm>
+            <a:off x="8138160" y="3931920"/>
+            <a:ext cx="3611880" cy="91440"/>
+          </a:xfrm>
+          <a:prstGeom prst="rect">
+            <a:avLst/>
+          </a:prstGeom>
+          <a:solidFill>
+            <a:srgbClr val="C87A1E"/>
+          </a:solidFill>
+          <a:ln>
+            <a:noFill/>
+          </a:ln>
+          <a:effectLst/>
+        </p:spPr>
+        <p:style>
+          <a:lnRef idx="1">
+            <a:schemeClr val="accent1"/>
+          </a:lnRef>
+          <a:fillRef idx="3">
+            <a:schemeClr val="accent1"/>
+          </a:fillRef>
+          <a:effectRef idx="2">
+            <a:schemeClr val="accent1"/>
+          </a:effectRef>
+          <a:fontRef idx="minor">
+            <a:schemeClr val="lt1"/>
+          </a:fontRef>
+        </p:style>
+        <p:txBody>
+          <a:bodyPr rtlCol="0" anchor="ctr"/>
+          <a:lstStyle/>
+          <a:p>
+            <a:pPr algn="ctr"/>
+          </a:p>
+        </p:txBody>
+      </p:sp>
+      <p:sp>
+        <p:nvSpPr>
+          <p:cNvPr id="27" name="TextBox 26"/>
+          <p:cNvSpPr txBox="1"/>
+          <p:nvPr/>
+        </p:nvSpPr>
+        <p:spPr>
+          <a:xfrm>
+            <a:off x="8321040" y="4114800"/>
+            <a:ext cx="3246120" cy="457200"/>
+          </a:xfrm>
+          <a:prstGeom prst="rect">
+            <a:avLst/>
+          </a:prstGeom>
+          <a:noFill/>
+        </p:spPr>
+        <p:txBody>
+          <a:bodyPr wrap="square" anchor="t">
+            <a:spAutoFit/>
+          </a:bodyPr>
+          <a:lstStyle/>
+          <a:p>
+            <a:pPr algn="l">
+              <a:spcAft>
+                <a:spcPts val="600"/>
+              </a:spcAft>
+            </a:pPr>
+            <a:r>
+              <a:rPr sz="1800" b="1">
+                <a:solidFill>
+                  <a:srgbClr val="C87A1E"/>
+                </a:solidFill>
+                <a:latin typeface="Georgia"/>
+              </a:rPr>
+              <a:t>Safe by default</a:t>
+            </a:r>
+          </a:p>
+        </p:txBody>
+      </p:sp>
+      <p:sp>
+        <p:nvSpPr>
+          <p:cNvPr id="28" name="TextBox 27"/>
+          <p:cNvSpPr txBox="1"/>
+          <p:nvPr/>
+        </p:nvSpPr>
+        <p:spPr>
+          <a:xfrm>
+            <a:off x="8321040" y="4617720"/>
+            <a:ext cx="3246120" cy="1371600"/>
+          </a:xfrm>
+          <a:prstGeom prst="rect">
+            <a:avLst/>
+          </a:prstGeom>
+          <a:noFill/>
+        </p:spPr>
+        <p:txBody>
+          <a:bodyPr wrap="square" anchor="t">
+            <a:spAutoFit/>
+          </a:bodyPr>
+          <a:lstStyle/>
+          <a:p>
+            <a:pPr algn="l">
+              <a:spcAft>
+                <a:spcPts val="600"/>
+              </a:spcAft>
+            </a:pPr>
+            <a:r>
+              <a:rPr sz="1400" b="0">
+                <a:solidFill>
+                  <a:srgbClr val="2B2020"/>
+                </a:solidFill>
+                <a:latin typeface="Calibri"/>
+              </a:rPr>
+              <a:t>HTTPS, hashed passwords, no AWS keys in app, dependency audits</a:t>
+            </a:r>
+          </a:p>
+        </p:txBody>
+      </p:sp>
+    </p:spTree>
+  </p:cSld>
+  <p:clrMapOvr>
+    <a:masterClrMapping/>
+  </p:clrMapOvr>
+</p:sld>
+</file>
+
+<file path=ppt/slides/slide12.xml><?xml version="1.0" encoding="utf-8"?>
+<p:sld xmlns:a="http://schemas.openxmlformats.org/drawingml/2006/main" xmlns:p="http://schemas.openxmlformats.org/presentationml/2006/main" xmlns:r="http://schemas.openxmlformats.org/officeDocument/2006/relationships">
+  <p:cSld>
+    <p:bg>
+      <p:bgPr>
+        <a:solidFill>
+          <a:srgbClr val="FAF5EA"/>
+        </a:solidFill>
+        <a:effectLst/>
+      </p:bgPr>
+    </p:bg>
+    <p:spTree>
+      <p:nvGrpSpPr>
+        <p:cNvPr id="1" name=""/>
+        <p:cNvGrpSpPr/>
+        <p:nvPr/>
+      </p:nvGrpSpPr>
+      <p:grpSpPr/>
+      <p:sp>
+        <p:nvSpPr>
+          <p:cNvPr id="2" name="Rectangle 1"/>
+          <p:cNvSpPr/>
+          <p:nvPr/>
+        </p:nvSpPr>
+        <p:spPr>
+          <a:xfrm>
+            <a:off x="0" y="0"/>
+            <a:ext cx="12191695" cy="109728"/>
+          </a:xfrm>
+          <a:prstGeom prst="rect">
+            <a:avLst/>
+          </a:prstGeom>
+          <a:solidFill>
+            <a:srgbClr val="C87A1E"/>
+          </a:solidFill>
+          <a:ln>
+            <a:noFill/>
+          </a:ln>
+          <a:effectLst/>
+        </p:spPr>
+        <p:style>
+          <a:lnRef idx="1">
+            <a:schemeClr val="accent1"/>
+          </a:lnRef>
+          <a:fillRef idx="3">
+            <a:schemeClr val="accent1"/>
+          </a:fillRef>
+          <a:effectRef idx="2">
+            <a:schemeClr val="accent1"/>
+          </a:effectRef>
+          <a:fontRef idx="minor">
+            <a:schemeClr val="lt1"/>
+          </a:fontRef>
+        </p:style>
+        <p:txBody>
+          <a:bodyPr rtlCol="0" anchor="ctr"/>
+          <a:lstStyle/>
+          <a:p>
+            <a:pPr algn="ctr"/>
+          </a:p>
+        </p:txBody>
+      </p:sp>
+      <p:sp>
+        <p:nvSpPr>
+          <p:cNvPr id="3" name="TextBox 2"/>
+          <p:cNvSpPr txBox="1"/>
+          <p:nvPr/>
+        </p:nvSpPr>
+        <p:spPr>
+          <a:xfrm>
+            <a:off x="548640" y="320040"/>
+            <a:ext cx="10972800" cy="822960"/>
+          </a:xfrm>
+          <a:prstGeom prst="rect">
+            <a:avLst/>
+          </a:prstGeom>
+          <a:noFill/>
+        </p:spPr>
+        <p:txBody>
+          <a:bodyPr wrap="square" anchor="t">
+            <a:spAutoFit/>
+          </a:bodyPr>
+          <a:lstStyle/>
+          <a:p>
+            <a:pPr algn="l">
+              <a:spcAft>
+                <a:spcPts val="600"/>
+              </a:spcAft>
+            </a:pPr>
+            <a:r>
+              <a:rPr sz="3200" b="1">
+                <a:solidFill>
+                  <a:srgbClr val="7B1A1A"/>
+                </a:solidFill>
+                <a:latin typeface="Georgia"/>
+              </a:rPr>
+              <a:t>Three packages</a:t>
+            </a:r>
+          </a:p>
+        </p:txBody>
+      </p:sp>
+      <p:sp>
+        <p:nvSpPr>
+          <p:cNvPr id="4" name="TextBox 3"/>
+          <p:cNvSpPr txBox="1"/>
+          <p:nvPr/>
+        </p:nvSpPr>
+        <p:spPr>
+          <a:xfrm>
+            <a:off x="548640" y="960120"/>
+            <a:ext cx="10972800" cy="457200"/>
+          </a:xfrm>
+          <a:prstGeom prst="rect">
+            <a:avLst/>
+          </a:prstGeom>
+          <a:noFill/>
+        </p:spPr>
+        <p:txBody>
+          <a:bodyPr wrap="square" anchor="t">
+            <a:spAutoFit/>
+          </a:bodyPr>
+          <a:lstStyle/>
+          <a:p>
+            <a:pPr algn="l">
+              <a:spcAft>
+                <a:spcPts val="600"/>
+              </a:spcAft>
+            </a:pPr>
+            <a:r>
+              <a:rPr sz="1600" b="0">
+                <a:solidFill>
+                  <a:srgbClr val="C87A1E"/>
+                </a:solidFill>
+                <a:latin typeface="Calibri"/>
+              </a:rPr>
+              <a:t>Same platform; choose what the temple needs today and grow later</a:t>
+            </a:r>
+          </a:p>
+        </p:txBody>
+      </p:sp>
+      <p:sp>
+        <p:nvSpPr>
+          <p:cNvPr id="5" name="TextBox 4"/>
+          <p:cNvSpPr txBox="1"/>
+          <p:nvPr/>
+        </p:nvSpPr>
+        <p:spPr>
+          <a:xfrm>
+            <a:off x="548640" y="6446520"/>
+            <a:ext cx="7315200" cy="274320"/>
+          </a:xfrm>
+          <a:prstGeom prst="rect">
+            <a:avLst/>
+          </a:prstGeom>
+          <a:noFill/>
+        </p:spPr>
+        <p:txBody>
+          <a:bodyPr wrap="square" anchor="t">
+            <a:spAutoFit/>
+          </a:bodyPr>
+          <a:lstStyle/>
+          <a:p>
+            <a:pPr algn="l">
+              <a:spcAft>
+                <a:spcPts val="600"/>
+              </a:spcAft>
+            </a:pPr>
+            <a:r>
+              <a:rPr sz="1000" b="0">
+                <a:solidFill>
+                  <a:srgbClr val="887777"/>
+                </a:solidFill>
+                <a:latin typeface="Calibri"/>
+              </a:rPr>
+              <a:t>Temple Platform  |  Vriksha Studio</a:t>
+            </a:r>
+          </a:p>
+        </p:txBody>
+      </p:sp>
+      <p:sp>
+        <p:nvSpPr>
+          <p:cNvPr id="6" name="Rectangle 5"/>
+          <p:cNvSpPr/>
+          <p:nvPr/>
+        </p:nvSpPr>
+        <p:spPr>
+          <a:xfrm>
+            <a:off x="548640" y="1554480"/>
+            <a:ext cx="3611880" cy="4572000"/>
+          </a:xfrm>
+          <a:prstGeom prst="rect">
+            <a:avLst/>
+          </a:prstGeom>
+          <a:solidFill>
+            <a:srgbClr val="FFFFFF"/>
+          </a:solidFill>
+          <a:ln w="12700">
+            <a:solidFill>
+              <a:srgbClr val="C87A1E"/>
+            </a:solidFill>
+          </a:ln>
+          <a:effectLst/>
+        </p:spPr>
+        <p:style>
+          <a:lnRef idx="1">
+            <a:schemeClr val="accent1"/>
+          </a:lnRef>
+          <a:fillRef idx="3">
+            <a:schemeClr val="accent1"/>
+          </a:fillRef>
+          <a:effectRef idx="2">
+            <a:schemeClr val="accent1"/>
+          </a:effectRef>
+          <a:fontRef idx="minor">
+            <a:schemeClr val="lt1"/>
+          </a:fontRef>
+        </p:style>
+        <p:txBody>
+          <a:bodyPr rtlCol="0" anchor="ctr"/>
+          <a:lstStyle/>
+          <a:p>
+            <a:pPr algn="ctr"/>
+          </a:p>
+        </p:txBody>
+      </p:sp>
+      <p:sp>
+        <p:nvSpPr>
           <p:cNvPr id="7" name="Rectangle 6"/>
           <p:cNvSpPr/>
           <p:nvPr/>
@@ -4479,7 +6758,7 @@
 </p:sld>
 </file>
 
-<file path=ppt/slides/slide11.xml><?xml version="1.0" encoding="utf-8"?>
+<file path=ppt/slides/slide13.xml><?xml version="1.0" encoding="utf-8"?>
 <p:sld xmlns:a="http://schemas.openxmlformats.org/drawingml/2006/main" xmlns:p="http://schemas.openxmlformats.org/presentationml/2006/main" xmlns:r="http://schemas.openxmlformats.org/officeDocument/2006/relationships">
   <p:cSld>
     <p:bg>
@@ -5484,7 +7763,7 @@
 </p:sld>
 </file>
 
-<file path=ppt/slides/slide12.xml><?xml version="1.0" encoding="utf-8"?>
+<file path=ppt/slides/slide14.xml><?xml version="1.0" encoding="utf-8"?>
 <p:sld xmlns:a="http://schemas.openxmlformats.org/drawingml/2006/main" xmlns:p="http://schemas.openxmlformats.org/presentationml/2006/main" xmlns:r="http://schemas.openxmlformats.org/officeDocument/2006/relationships">
   <p:cSld>
     <p:bg>
@@ -7460,7 +9739,7 @@
       </p:sp>
       <p:pic>
         <p:nvPicPr>
-          <p:cNvPr id="7" name="Picture 6" descr="home_c.png"/>
+          <p:cNvPr id="7" name="Picture 6" descr="home.png"/>
           <p:cNvPicPr>
             <a:picLocks noChangeAspect="1"/>
           </p:cNvPicPr>
@@ -8132,7 +10411,7 @@
       </p:sp>
       <p:pic>
         <p:nvPicPr>
-          <p:cNvPr id="7" name="Picture 6" descr="telugu_c.png"/>
+          <p:cNvPr id="7" name="Picture 6" descr="telugu.png"/>
           <p:cNvPicPr>
             <a:picLocks noChangeAspect="1"/>
           </p:cNvPicPr>
@@ -8202,7 +10481,7 @@
       </p:sp>
       <p:pic>
         <p:nvPicPr>
-          <p:cNvPr id="9" name="Picture 8" descr="mobile_c.png"/>
+          <p:cNvPr id="9" name="Picture 8" descr="mobile.png"/>
           <p:cNvPicPr>
             <a:picLocks noChangeAspect="1"/>
           </p:cNvPicPr>
@@ -8747,7 +11026,7 @@
       </p:sp>
       <p:pic>
         <p:nvPicPr>
-          <p:cNvPr id="7" name="Picture 6" descr="login_c.png"/>
+          <p:cNvPr id="7" name="Picture 6" descr="poojas.png"/>
           <p:cNvPicPr>
             <a:picLocks noChangeAspect="1"/>
           </p:cNvPicPr>
@@ -9522,7 +11801,7 @@
                 </a:solidFill>
                 <a:latin typeface="Georgia"/>
               </a:rPr>
-              <a:t>Donations with transparency</a:t>
+              <a:t>Donations and finance with transparency</a:t>
             </a:r>
           </a:p>
         </p:txBody>
@@ -9561,7 +11840,7 @@
                 </a:solidFill>
                 <a:latin typeface="Calibri"/>
               </a:rPr>
-              <a:t>Archive of historical donors today, online giving as an add-on</a:t>
+              <a:t>Every donation and paid seva posts to the ledger automatically</a:t>
             </a:r>
           </a:p>
         </p:txBody>
@@ -9653,7 +11932,7 @@
       </p:sp>
       <p:pic>
         <p:nvPicPr>
-          <p:cNvPr id="7" name="Picture 6" descr="donations_c.png"/>
+          <p:cNvPr id="7" name="Picture 6" descr="admin_finance.png"/>
           <p:cNvPicPr>
             <a:picLocks noChangeAspect="1"/>
           </p:cNvPicPr>
@@ -9753,7 +12032,7 @@
                 </a:solidFill>
                 <a:latin typeface="Calibri"/>
               </a:rPr>
-              <a:t>Historic donors, land and item donors, committee archive</a:t>
+              <a:t>Donors and donations recorded by staff</a:t>
             </a:r>
           </a:p>
         </p:txBody>
@@ -9836,7 +12115,7 @@
                 </a:solidFill>
                 <a:latin typeface="Calibri"/>
               </a:rPr>
-              <a:t>Admin records donations and issues PDF receipts</a:t>
+              <a:t>PDF receipts; once issued they cannot be edited or deleted</a:t>
             </a:r>
           </a:p>
         </p:txBody>
@@ -9919,7 +12198,7 @@
                 </a:solidFill>
                 <a:latin typeface="Calibri"/>
               </a:rPr>
-              <a:t>A receipt, once issued, cannot be edited or deleted</a:t>
+              <a:t>Income by source, expenses by category</a:t>
             </a:r>
           </a:p>
         </p:txBody>
@@ -10002,7 +12281,7 @@
                 </a:solidFill>
                 <a:latin typeface="Calibri"/>
               </a:rPr>
-              <a:t>Every rupee posts to the finance ledger</a:t>
+              <a:t>CSV and PDF ledger export</a:t>
             </a:r>
           </a:p>
         </p:txBody>
@@ -12230,7 +14509,7 @@
                 </a:solidFill>
                 <a:latin typeface="Georgia"/>
               </a:rPr>
-              <a:t>How it is built</a:t>
+              <a:t>Admin in action</a:t>
             </a:r>
           </a:p>
         </p:txBody>
@@ -12269,7 +14548,7 @@
                 </a:solidFill>
                 <a:latin typeface="Calibri"/>
               </a:rPr>
-              <a:t>Modern, tested, containerised: low cost to run, easy to hand over</a:t>
+              <a:t>Seeded demo data: dashboard, counter tickets, collect payment, QR scan</a:t>
             </a:r>
           </a:p>
         </p:txBody>
@@ -12315,16 +14594,16 @@
       </p:sp>
       <p:sp>
         <p:nvSpPr>
-          <p:cNvPr id="6" name="Rounded Rectangle 5"/>
+          <p:cNvPr id="6" name="Rectangle 5"/>
           <p:cNvSpPr/>
           <p:nvPr/>
         </p:nvSpPr>
         <p:spPr>
           <a:xfrm>
-            <a:off x="548640" y="2011680"/>
-            <a:ext cx="2011680" cy="1188720"/>
-          </a:xfrm>
-          <a:prstGeom prst="roundRect">
+            <a:off x="502919" y="1508760"/>
+            <a:ext cx="5577840" cy="3520440"/>
+          </a:xfrm>
+          <a:prstGeom prst="rect">
             <a:avLst/>
           </a:prstGeom>
           <a:solidFill>
@@ -12332,7 +14611,7 @@
           </a:solidFill>
           <a:ln w="12700">
             <a:solidFill>
-              <a:srgbClr val="7B1A1A"/>
+              <a:srgbClr val="D8C8B0"/>
             </a:solidFill>
           </a:ln>
           <a:effectLst/>
@@ -12359,112 +14638,42 @@
           </a:p>
         </p:txBody>
       </p:sp>
-      <p:sp>
-        <p:nvSpPr>
-          <p:cNvPr id="7" name="TextBox 6"/>
-          <p:cNvSpPr txBox="1"/>
-          <p:nvPr/>
-        </p:nvSpPr>
-        <p:spPr>
-          <a:xfrm>
-            <a:off x="548640" y="2011680"/>
-            <a:ext cx="2011680" cy="1188720"/>
-          </a:xfrm>
-          <a:prstGeom prst="rect">
-            <a:avLst/>
-          </a:prstGeom>
-          <a:noFill/>
-        </p:spPr>
-        <p:txBody>
-          <a:bodyPr wrap="square" anchor="ctr">
-            <a:spAutoFit/>
-          </a:bodyPr>
-          <a:lstStyle/>
-          <a:p>
-            <a:pPr algn="ctr">
-              <a:spcAft>
-                <a:spcPts val="600"/>
-              </a:spcAft>
-            </a:pPr>
-            <a:r>
-              <a:rPr sz="1300" b="1">
-                <a:solidFill>
-                  <a:srgbClr val="7B1A1A"/>
-                </a:solidFill>
-                <a:latin typeface="Calibri"/>
-              </a:rPr>
-              <a:t>Devotee / Staff</a:t>
-            </a:r>
-          </a:p>
-          <a:p>
-            <a:pPr algn="ctr">
-              <a:spcAft>
-                <a:spcPts val="600"/>
-              </a:spcAft>
-            </a:pPr>
-            <a:r>
-              <a:rPr sz="1300" b="1">
-                <a:solidFill>
-                  <a:srgbClr val="7B1A1A"/>
-                </a:solidFill>
-                <a:latin typeface="Calibri"/>
-              </a:rPr>
-              <a:t>(browser)</a:t>
-            </a:r>
-          </a:p>
-        </p:txBody>
-      </p:sp>
-      <p:sp>
-        <p:nvSpPr>
-          <p:cNvPr id="8" name="TextBox 7"/>
-          <p:cNvSpPr txBox="1"/>
-          <p:nvPr/>
-        </p:nvSpPr>
-        <p:spPr>
-          <a:xfrm>
-            <a:off x="2514600" y="2286000"/>
-            <a:ext cx="365760" cy="457200"/>
-          </a:xfrm>
-          <a:prstGeom prst="rect">
-            <a:avLst/>
-          </a:prstGeom>
-          <a:noFill/>
-        </p:spPr>
-        <p:txBody>
-          <a:bodyPr wrap="square" anchor="t">
-            <a:spAutoFit/>
-          </a:bodyPr>
-          <a:lstStyle/>
-          <a:p>
-            <a:pPr algn="l">
-              <a:spcAft>
-                <a:spcPts val="600"/>
-              </a:spcAft>
-            </a:pPr>
-            <a:r>
-              <a:rPr sz="2200" b="1">
-                <a:solidFill>
-                  <a:srgbClr val="C87A1E"/>
-                </a:solidFill>
-                <a:latin typeface="Calibri"/>
-              </a:rPr>
-              <a:t>&gt;</a:t>
-            </a:r>
-          </a:p>
-        </p:txBody>
-      </p:sp>
-      <p:sp>
-        <p:nvSpPr>
-          <p:cNvPr id="9" name="Rounded Rectangle 8"/>
+      <p:pic>
+        <p:nvPicPr>
+          <p:cNvPr id="7" name="Picture 6" descr="admin_dashboard.png"/>
+          <p:cNvPicPr>
+            <a:picLocks noChangeAspect="1"/>
+          </p:cNvPicPr>
+          <p:nvPr/>
+        </p:nvPicPr>
+        <p:blipFill>
+          <a:blip r:embed="rId2"/>
+          <a:stretch>
+            <a:fillRect/>
+          </a:stretch>
+        </p:blipFill>
+        <p:spPr>
+          <a:xfrm>
+            <a:off x="548640" y="1554480"/>
+            <a:ext cx="5486400" cy="3429000"/>
+          </a:xfrm>
+          <a:prstGeom prst="rect">
+            <a:avLst/>
+          </a:prstGeom>
+        </p:spPr>
+      </p:pic>
+      <p:sp>
+        <p:nvSpPr>
+          <p:cNvPr id="8" name="Rectangle 7"/>
           <p:cNvSpPr/>
           <p:nvPr/>
         </p:nvSpPr>
         <p:spPr>
           <a:xfrm>
-            <a:off x="2743200" y="2011680"/>
-            <a:ext cx="2011680" cy="1188720"/>
-          </a:xfrm>
-          <a:prstGeom prst="roundRect">
+            <a:off x="6172200" y="1508760"/>
+            <a:ext cx="5577840" cy="3520440"/>
+          </a:xfrm>
+          <a:prstGeom prst="rect">
             <a:avLst/>
           </a:prstGeom>
           <a:solidFill>
@@ -12472,7 +14681,7 @@
           </a:solidFill>
           <a:ln w="12700">
             <a:solidFill>
-              <a:srgbClr val="7B1A1A"/>
+              <a:srgbClr val="D8C8B0"/>
             </a:solidFill>
           </a:ln>
           <a:effectLst/>
@@ -12499,6 +14708,30 @@
           </a:p>
         </p:txBody>
       </p:sp>
+      <p:pic>
+        <p:nvPicPr>
+          <p:cNvPr id="9" name="Picture 8" descr="admin_tickets.png"/>
+          <p:cNvPicPr>
+            <a:picLocks noChangeAspect="1"/>
+          </p:cNvPicPr>
+          <p:nvPr/>
+        </p:nvPicPr>
+        <p:blipFill>
+          <a:blip r:embed="rId3"/>
+          <a:stretch>
+            <a:fillRect/>
+          </a:stretch>
+        </p:blipFill>
+        <p:spPr>
+          <a:xfrm>
+            <a:off x="6217920" y="1554480"/>
+            <a:ext cx="5486400" cy="3429000"/>
+          </a:xfrm>
+          <a:prstGeom prst="rect">
+            <a:avLst/>
+          </a:prstGeom>
+        </p:spPr>
+      </p:pic>
       <p:sp>
         <p:nvSpPr>
           <p:cNvPr id="10" name="TextBox 9"/>
@@ -12507,63 +14740,8 @@
         </p:nvSpPr>
         <p:spPr>
           <a:xfrm>
-            <a:off x="2743200" y="2011680"/>
-            <a:ext cx="2011680" cy="1188720"/>
-          </a:xfrm>
-          <a:prstGeom prst="rect">
-            <a:avLst/>
-          </a:prstGeom>
-          <a:noFill/>
-        </p:spPr>
-        <p:txBody>
-          <a:bodyPr wrap="square" anchor="ctr">
-            <a:spAutoFit/>
-          </a:bodyPr>
-          <a:lstStyle/>
-          <a:p>
-            <a:pPr algn="ctr">
-              <a:spcAft>
-                <a:spcPts val="600"/>
-              </a:spcAft>
-            </a:pPr>
-            <a:r>
-              <a:rPr sz="1300" b="1">
-                <a:solidFill>
-                  <a:srgbClr val="7B1A1A"/>
-                </a:solidFill>
-                <a:latin typeface="Calibri"/>
-              </a:rPr>
-              <a:t>Nginx + TLS</a:t>
-            </a:r>
-          </a:p>
-          <a:p>
-            <a:pPr algn="ctr">
-              <a:spcAft>
-                <a:spcPts val="600"/>
-              </a:spcAft>
-            </a:pPr>
-            <a:r>
-              <a:rPr sz="1300" b="1">
-                <a:solidFill>
-                  <a:srgbClr val="7B1A1A"/>
-                </a:solidFill>
-                <a:latin typeface="Calibri"/>
-              </a:rPr>
-              <a:t>(Let's Encrypt)</a:t>
-            </a:r>
-          </a:p>
-        </p:txBody>
-      </p:sp>
-      <p:sp>
-        <p:nvSpPr>
-          <p:cNvPr id="11" name="TextBox 10"/>
-          <p:cNvSpPr txBox="1"/>
-          <p:nvPr/>
-        </p:nvSpPr>
-        <p:spPr>
-          <a:xfrm>
-            <a:off x="4709160" y="2286000"/>
-            <a:ext cx="365760" cy="457200"/>
+            <a:off x="548640" y="5349240"/>
+            <a:ext cx="10972800" cy="1097280"/>
           </a:xfrm>
           <a:prstGeom prst="rect">
             <a:avLst/>
@@ -12582,139 +14760,15 @@
               </a:spcAft>
             </a:pPr>
             <a:r>
-              <a:rPr sz="2200" b="1">
-                <a:solidFill>
-                  <a:srgbClr val="C87A1E"/>
-                </a:solidFill>
-                <a:latin typeface="Calibri"/>
-              </a:rPr>
-              <a:t>&gt;</a:t>
-            </a:r>
-          </a:p>
-        </p:txBody>
-      </p:sp>
-      <p:sp>
-        <p:nvSpPr>
-          <p:cNvPr id="12" name="Rounded Rectangle 11"/>
-          <p:cNvSpPr/>
-          <p:nvPr/>
-        </p:nvSpPr>
-        <p:spPr>
-          <a:xfrm>
-            <a:off x="4937760" y="2011680"/>
-            <a:ext cx="2011680" cy="1188720"/>
-          </a:xfrm>
-          <a:prstGeom prst="roundRect">
-            <a:avLst/>
-          </a:prstGeom>
-          <a:solidFill>
-            <a:srgbClr val="7B1A1A"/>
-          </a:solidFill>
-          <a:ln w="12700">
-            <a:solidFill>
-              <a:srgbClr val="7B1A1A"/>
-            </a:solidFill>
-          </a:ln>
-          <a:effectLst/>
-        </p:spPr>
-        <p:style>
-          <a:lnRef idx="1">
-            <a:schemeClr val="accent1"/>
-          </a:lnRef>
-          <a:fillRef idx="3">
-            <a:schemeClr val="accent1"/>
-          </a:fillRef>
-          <a:effectRef idx="2">
-            <a:schemeClr val="accent1"/>
-          </a:effectRef>
-          <a:fontRef idx="minor">
-            <a:schemeClr val="lt1"/>
-          </a:fontRef>
-        </p:style>
-        <p:txBody>
-          <a:bodyPr rtlCol="0" anchor="ctr"/>
-          <a:lstStyle/>
-          <a:p>
-            <a:pPr algn="ctr"/>
-          </a:p>
-        </p:txBody>
-      </p:sp>
-      <p:sp>
-        <p:nvSpPr>
-          <p:cNvPr id="13" name="TextBox 12"/>
-          <p:cNvSpPr txBox="1"/>
-          <p:nvPr/>
-        </p:nvSpPr>
-        <p:spPr>
-          <a:xfrm>
-            <a:off x="4937760" y="2011680"/>
-            <a:ext cx="2011680" cy="1188720"/>
-          </a:xfrm>
-          <a:prstGeom prst="rect">
-            <a:avLst/>
-          </a:prstGeom>
-          <a:noFill/>
-        </p:spPr>
-        <p:txBody>
-          <a:bodyPr wrap="square" anchor="ctr">
-            <a:spAutoFit/>
-          </a:bodyPr>
-          <a:lstStyle/>
-          <a:p>
-            <a:pPr algn="ctr">
-              <a:spcAft>
-                <a:spcPts val="600"/>
-              </a:spcAft>
-            </a:pPr>
-            <a:r>
-              <a:rPr sz="1300" b="1">
-                <a:solidFill>
-                  <a:srgbClr val="FFFFFF"/>
-                </a:solidFill>
-                <a:latin typeface="Calibri"/>
-              </a:rPr>
-              <a:t>Next.js 15 + React 19</a:t>
-            </a:r>
-          </a:p>
-          <a:p>
-            <a:pPr algn="ctr">
-              <a:spcAft>
-                <a:spcPts val="600"/>
-              </a:spcAft>
-            </a:pPr>
-            <a:r>
-              <a:rPr sz="1300" b="1">
-                <a:solidFill>
-                  <a:srgbClr val="FFFFFF"/>
-                </a:solidFill>
-                <a:latin typeface="Calibri"/>
-              </a:rPr>
-              <a:t>public site, admin UI</a:t>
-            </a:r>
-          </a:p>
-        </p:txBody>
-      </p:sp>
-      <p:sp>
-        <p:nvSpPr>
-          <p:cNvPr id="14" name="TextBox 13"/>
-          <p:cNvSpPr txBox="1"/>
-          <p:nvPr/>
-        </p:nvSpPr>
-        <p:spPr>
-          <a:xfrm>
-            <a:off x="6903720" y="2286000"/>
-            <a:ext cx="365760" cy="457200"/>
-          </a:xfrm>
-          <a:prstGeom prst="rect">
-            <a:avLst/>
-          </a:prstGeom>
-          <a:noFill/>
-        </p:spPr>
-        <p:txBody>
-          <a:bodyPr wrap="square" anchor="t">
-            <a:spAutoFit/>
-          </a:bodyPr>
-          <a:lstStyle/>
+              <a:rPr sz="1600" b="0">
+                <a:solidFill>
+                  <a:srgbClr val="2B2020"/>
+                </a:solidFill>
+                <a:latin typeface="Calibri"/>
+              </a:rPr>
+              <a:t>Dashboard shows what needs attention; recent changes come from the audit log.</a:t>
+            </a:r>
+          </a:p>
           <a:p>
             <a:pPr algn="l">
               <a:spcAft>
@@ -12722,527 +14776,13 @@
               </a:spcAft>
             </a:pPr>
             <a:r>
-              <a:rPr sz="2200" b="1">
-                <a:solidFill>
-                  <a:srgbClr val="C87A1E"/>
-                </a:solidFill>
-                <a:latin typeface="Calibri"/>
-              </a:rPr>
-              <a:t>&gt;</a:t>
-            </a:r>
-          </a:p>
-        </p:txBody>
-      </p:sp>
-      <p:sp>
-        <p:nvSpPr>
-          <p:cNvPr id="15" name="Rounded Rectangle 14"/>
-          <p:cNvSpPr/>
-          <p:nvPr/>
-        </p:nvSpPr>
-        <p:spPr>
-          <a:xfrm>
-            <a:off x="7315200" y="2011680"/>
-            <a:ext cx="2011680" cy="1188720"/>
-          </a:xfrm>
-          <a:prstGeom prst="roundRect">
-            <a:avLst/>
-          </a:prstGeom>
-          <a:solidFill>
-            <a:srgbClr val="7B1A1A"/>
-          </a:solidFill>
-          <a:ln w="12700">
-            <a:solidFill>
-              <a:srgbClr val="7B1A1A"/>
-            </a:solidFill>
-          </a:ln>
-          <a:effectLst/>
-        </p:spPr>
-        <p:style>
-          <a:lnRef idx="1">
-            <a:schemeClr val="accent1"/>
-          </a:lnRef>
-          <a:fillRef idx="3">
-            <a:schemeClr val="accent1"/>
-          </a:fillRef>
-          <a:effectRef idx="2">
-            <a:schemeClr val="accent1"/>
-          </a:effectRef>
-          <a:fontRef idx="minor">
-            <a:schemeClr val="lt1"/>
-          </a:fontRef>
-        </p:style>
-        <p:txBody>
-          <a:bodyPr rtlCol="0" anchor="ctr"/>
-          <a:lstStyle/>
-          <a:p>
-            <a:pPr algn="ctr"/>
-          </a:p>
-        </p:txBody>
-      </p:sp>
-      <p:sp>
-        <p:nvSpPr>
-          <p:cNvPr id="16" name="TextBox 15"/>
-          <p:cNvSpPr txBox="1"/>
-          <p:nvPr/>
-        </p:nvSpPr>
-        <p:spPr>
-          <a:xfrm>
-            <a:off x="7315200" y="2011680"/>
-            <a:ext cx="2011680" cy="1188720"/>
-          </a:xfrm>
-          <a:prstGeom prst="rect">
-            <a:avLst/>
-          </a:prstGeom>
-          <a:noFill/>
-        </p:spPr>
-        <p:txBody>
-          <a:bodyPr wrap="square" anchor="ctr">
-            <a:spAutoFit/>
-          </a:bodyPr>
-          <a:lstStyle/>
-          <a:p>
-            <a:pPr algn="ctr">
-              <a:spcAft>
-                <a:spcPts val="600"/>
-              </a:spcAft>
-            </a:pPr>
-            <a:r>
-              <a:rPr sz="1300" b="1">
-                <a:solidFill>
-                  <a:srgbClr val="FFFFFF"/>
-                </a:solidFill>
-                <a:latin typeface="Calibri"/>
-              </a:rPr>
-              <a:t>FastAPI (Python)</a:t>
-            </a:r>
-          </a:p>
-          <a:p>
-            <a:pPr algn="ctr">
-              <a:spcAft>
-                <a:spcPts val="600"/>
-              </a:spcAft>
-            </a:pPr>
-            <a:r>
-              <a:rPr sz="1300" b="1">
-                <a:solidFill>
-                  <a:srgbClr val="FFFFFF"/>
-                </a:solidFill>
-                <a:latin typeface="Calibri"/>
-              </a:rPr>
-              <a:t>52 REST endpoints, RBAC</a:t>
-            </a:r>
-          </a:p>
-        </p:txBody>
-      </p:sp>
-      <p:sp>
-        <p:nvSpPr>
-          <p:cNvPr id="17" name="TextBox 16"/>
-          <p:cNvSpPr txBox="1"/>
-          <p:nvPr/>
-        </p:nvSpPr>
-        <p:spPr>
-          <a:xfrm>
-            <a:off x="9281160" y="2286000"/>
-            <a:ext cx="365760" cy="457200"/>
-          </a:xfrm>
-          <a:prstGeom prst="rect">
-            <a:avLst/>
-          </a:prstGeom>
-          <a:noFill/>
-        </p:spPr>
-        <p:txBody>
-          <a:bodyPr wrap="square" anchor="t">
-            <a:spAutoFit/>
-          </a:bodyPr>
-          <a:lstStyle/>
-          <a:p>
-            <a:pPr algn="l">
-              <a:spcAft>
-                <a:spcPts val="600"/>
-              </a:spcAft>
-            </a:pPr>
-            <a:r>
-              <a:rPr sz="2200" b="1">
-                <a:solidFill>
-                  <a:srgbClr val="C87A1E"/>
-                </a:solidFill>
-                <a:latin typeface="Calibri"/>
-              </a:rPr>
-              <a:t>&gt;</a:t>
-            </a:r>
-          </a:p>
-        </p:txBody>
-      </p:sp>
-      <p:sp>
-        <p:nvSpPr>
-          <p:cNvPr id="18" name="Rounded Rectangle 17"/>
-          <p:cNvSpPr/>
-          <p:nvPr/>
-        </p:nvSpPr>
-        <p:spPr>
-          <a:xfrm>
-            <a:off x="9784080" y="2011680"/>
-            <a:ext cx="2011680" cy="1188720"/>
-          </a:xfrm>
-          <a:prstGeom prst="roundRect">
-            <a:avLst/>
-          </a:prstGeom>
-          <a:solidFill>
-            <a:srgbClr val="C87A1E"/>
-          </a:solidFill>
-          <a:ln w="12700">
-            <a:solidFill>
-              <a:srgbClr val="7B1A1A"/>
-            </a:solidFill>
-          </a:ln>
-          <a:effectLst/>
-        </p:spPr>
-        <p:style>
-          <a:lnRef idx="1">
-            <a:schemeClr val="accent1"/>
-          </a:lnRef>
-          <a:fillRef idx="3">
-            <a:schemeClr val="accent1"/>
-          </a:fillRef>
-          <a:effectRef idx="2">
-            <a:schemeClr val="accent1"/>
-          </a:effectRef>
-          <a:fontRef idx="minor">
-            <a:schemeClr val="lt1"/>
-          </a:fontRef>
-        </p:style>
-        <p:txBody>
-          <a:bodyPr rtlCol="0" anchor="ctr"/>
-          <a:lstStyle/>
-          <a:p>
-            <a:pPr algn="ctr"/>
-          </a:p>
-        </p:txBody>
-      </p:sp>
-      <p:sp>
-        <p:nvSpPr>
-          <p:cNvPr id="19" name="TextBox 18"/>
-          <p:cNvSpPr txBox="1"/>
-          <p:nvPr/>
-        </p:nvSpPr>
-        <p:spPr>
-          <a:xfrm>
-            <a:off x="9784080" y="2011680"/>
-            <a:ext cx="2011680" cy="1188720"/>
-          </a:xfrm>
-          <a:prstGeom prst="rect">
-            <a:avLst/>
-          </a:prstGeom>
-          <a:noFill/>
-        </p:spPr>
-        <p:txBody>
-          <a:bodyPr wrap="square" anchor="ctr">
-            <a:spAutoFit/>
-          </a:bodyPr>
-          <a:lstStyle/>
-          <a:p>
-            <a:pPr algn="ctr">
-              <a:spcAft>
-                <a:spcPts val="600"/>
-              </a:spcAft>
-            </a:pPr>
-            <a:r>
-              <a:rPr sz="1300" b="1">
-                <a:solidFill>
-                  <a:srgbClr val="FFFFFF"/>
-                </a:solidFill>
-                <a:latin typeface="Calibri"/>
-              </a:rPr>
-              <a:t>PostgreSQL</a:t>
-            </a:r>
-          </a:p>
-        </p:txBody>
-      </p:sp>
-      <p:sp>
-        <p:nvSpPr>
-          <p:cNvPr id="20" name="Rounded Rectangle 19"/>
-          <p:cNvSpPr/>
-          <p:nvPr/>
-        </p:nvSpPr>
-        <p:spPr>
-          <a:xfrm>
-            <a:off x="5760720" y="3931920"/>
-            <a:ext cx="2286000" cy="914400"/>
-          </a:xfrm>
-          <a:prstGeom prst="roundRect">
-            <a:avLst/>
-          </a:prstGeom>
-          <a:solidFill>
-            <a:srgbClr val="FFFFFF"/>
-          </a:solidFill>
-          <a:ln w="12700">
-            <a:solidFill>
-              <a:srgbClr val="C87A1E"/>
-            </a:solidFill>
-          </a:ln>
-          <a:effectLst/>
-        </p:spPr>
-        <p:style>
-          <a:lnRef idx="1">
-            <a:schemeClr val="accent1"/>
-          </a:lnRef>
-          <a:fillRef idx="3">
-            <a:schemeClr val="accent1"/>
-          </a:fillRef>
-          <a:effectRef idx="2">
-            <a:schemeClr val="accent1"/>
-          </a:effectRef>
-          <a:fontRef idx="minor">
-            <a:schemeClr val="lt1"/>
-          </a:fontRef>
-        </p:style>
-        <p:txBody>
-          <a:bodyPr rtlCol="0" anchor="ctr"/>
-          <a:lstStyle/>
-          <a:p>
-            <a:pPr algn="ctr"/>
-          </a:p>
-        </p:txBody>
-      </p:sp>
-      <p:sp>
-        <p:nvSpPr>
-          <p:cNvPr id="21" name="TextBox 20"/>
-          <p:cNvSpPr txBox="1"/>
-          <p:nvPr/>
-        </p:nvSpPr>
-        <p:spPr>
-          <a:xfrm>
-            <a:off x="5760720" y="3931920"/>
-            <a:ext cx="2286000" cy="914400"/>
-          </a:xfrm>
-          <a:prstGeom prst="rect">
-            <a:avLst/>
-          </a:prstGeom>
-          <a:noFill/>
-        </p:spPr>
-        <p:txBody>
-          <a:bodyPr wrap="square" anchor="ctr">
-            <a:spAutoFit/>
-          </a:bodyPr>
-          <a:lstStyle/>
-          <a:p>
-            <a:pPr algn="ctr">
-              <a:spcAft>
-                <a:spcPts val="600"/>
-              </a:spcAft>
-            </a:pPr>
-            <a:r>
-              <a:rPr sz="1200" b="1">
+              <a:rPr sz="1600" b="0">
                 <a:solidFill>
                   <a:srgbClr val="2B2020"/>
                 </a:solidFill>
                 <a:latin typeface="Calibri"/>
               </a:rPr>
-              <a:t>AWS S3</a:t>
-            </a:r>
-          </a:p>
-          <a:p>
-            <a:pPr algn="ctr">
-              <a:spcAft>
-                <a:spcPts val="600"/>
-              </a:spcAft>
-            </a:pPr>
-            <a:r>
-              <a:rPr sz="1200" b="1">
-                <a:solidFill>
-                  <a:srgbClr val="2B2020"/>
-                </a:solidFill>
-                <a:latin typeface="Calibri"/>
-              </a:rPr>
-              <a:t>gallery, tickets, receipts</a:t>
-            </a:r>
-          </a:p>
-        </p:txBody>
-      </p:sp>
-      <p:sp>
-        <p:nvSpPr>
-          <p:cNvPr id="22" name="Rounded Rectangle 21"/>
-          <p:cNvSpPr/>
-          <p:nvPr/>
-        </p:nvSpPr>
-        <p:spPr>
-          <a:xfrm>
-            <a:off x="8229600" y="3931920"/>
-            <a:ext cx="2286000" cy="914400"/>
-          </a:xfrm>
-          <a:prstGeom prst="roundRect">
-            <a:avLst/>
-          </a:prstGeom>
-          <a:solidFill>
-            <a:srgbClr val="FFFFFF"/>
-          </a:solidFill>
-          <a:ln w="12700">
-            <a:solidFill>
-              <a:srgbClr val="C87A1E"/>
-            </a:solidFill>
-          </a:ln>
-          <a:effectLst/>
-        </p:spPr>
-        <p:style>
-          <a:lnRef idx="1">
-            <a:schemeClr val="accent1"/>
-          </a:lnRef>
-          <a:fillRef idx="3">
-            <a:schemeClr val="accent1"/>
-          </a:fillRef>
-          <a:effectRef idx="2">
-            <a:schemeClr val="accent1"/>
-          </a:effectRef>
-          <a:fontRef idx="minor">
-            <a:schemeClr val="lt1"/>
-          </a:fontRef>
-        </p:style>
-        <p:txBody>
-          <a:bodyPr rtlCol="0" anchor="ctr"/>
-          <a:lstStyle/>
-          <a:p>
-            <a:pPr algn="ctr"/>
-          </a:p>
-        </p:txBody>
-      </p:sp>
-      <p:sp>
-        <p:nvSpPr>
-          <p:cNvPr id="23" name="TextBox 22"/>
-          <p:cNvSpPr txBox="1"/>
-          <p:nvPr/>
-        </p:nvSpPr>
-        <p:spPr>
-          <a:xfrm>
-            <a:off x="8229600" y="3931920"/>
-            <a:ext cx="2286000" cy="914400"/>
-          </a:xfrm>
-          <a:prstGeom prst="rect">
-            <a:avLst/>
-          </a:prstGeom>
-          <a:noFill/>
-        </p:spPr>
-        <p:txBody>
-          <a:bodyPr wrap="square" anchor="ctr">
-            <a:spAutoFit/>
-          </a:bodyPr>
-          <a:lstStyle/>
-          <a:p>
-            <a:pPr algn="ctr">
-              <a:spcAft>
-                <a:spcPts val="600"/>
-              </a:spcAft>
-            </a:pPr>
-            <a:r>
-              <a:rPr sz="1200" b="1">
-                <a:solidFill>
-                  <a:srgbClr val="2B2020"/>
-                </a:solidFill>
-                <a:latin typeface="Calibri"/>
-              </a:rPr>
-              <a:t>AWS SES</a:t>
-            </a:r>
-          </a:p>
-          <a:p>
-            <a:pPr algn="ctr">
-              <a:spcAft>
-                <a:spcPts val="600"/>
-              </a:spcAft>
-            </a:pPr>
-            <a:r>
-              <a:rPr sz="1200" b="1">
-                <a:solidFill>
-                  <a:srgbClr val="2B2020"/>
-                </a:solidFill>
-                <a:latin typeface="Calibri"/>
-              </a:rPr>
-              <a:t>OTP, confirmations, alerts</a:t>
-            </a:r>
-          </a:p>
-        </p:txBody>
-      </p:sp>
-      <p:sp>
-        <p:nvSpPr>
-          <p:cNvPr id="24" name="TextBox 23"/>
-          <p:cNvSpPr txBox="1"/>
-          <p:nvPr/>
-        </p:nvSpPr>
-        <p:spPr>
-          <a:xfrm>
-            <a:off x="548640" y="3749039"/>
-            <a:ext cx="4937760" cy="2560320"/>
-          </a:xfrm>
-          <a:prstGeom prst="rect">
-            <a:avLst/>
-          </a:prstGeom>
-          <a:noFill/>
-        </p:spPr>
-        <p:txBody>
-          <a:bodyPr wrap="square" anchor="t">
-            <a:spAutoFit/>
-          </a:bodyPr>
-          <a:lstStyle/>
-          <a:p>
-            <a:pPr algn="l">
-              <a:spcAft>
-                <a:spcPts val="600"/>
-              </a:spcAft>
-            </a:pPr>
-            <a:r>
-              <a:rPr sz="1500" b="0">
-                <a:solidFill>
-                  <a:srgbClr val="2B2020"/>
-                </a:solidFill>
-                <a:latin typeface="Calibri"/>
-              </a:rPr>
-              <a:t>One server per temple: ~₹1,000 a month</a:t>
-            </a:r>
-          </a:p>
-          <a:p>
-            <a:pPr algn="l">
-              <a:spcAft>
-                <a:spcPts val="600"/>
-              </a:spcAft>
-            </a:pPr>
-            <a:r>
-              <a:rPr sz="1500" b="0">
-                <a:solidFill>
-                  <a:srgbClr val="2B2020"/>
-                </a:solidFill>
-                <a:latin typeface="Calibri"/>
-              </a:rPr>
-              <a:t>Docker Compose; GitHub Actions deploys after tests pass</a:t>
-            </a:r>
-          </a:p>
-          <a:p>
-            <a:pPr algn="l">
-              <a:spcAft>
-                <a:spcPts val="600"/>
-              </a:spcAft>
-            </a:pPr>
-            <a:r>
-              <a:rPr sz="1500" b="0">
-                <a:solidFill>
-                  <a:srgbClr val="2B2020"/>
-                </a:solidFill>
-                <a:latin typeface="Calibri"/>
-              </a:rPr>
-              <a:t>21 versioned DB migrations, ~40 test modules</a:t>
-            </a:r>
-          </a:p>
-          <a:p>
-            <a:pPr algn="l">
-              <a:spcAft>
-                <a:spcPts val="600"/>
-              </a:spcAft>
-            </a:pPr>
-            <a:r>
-              <a:rPr sz="1500" b="0">
-                <a:solidFill>
-                  <a:srgbClr val="2B2020"/>
-                </a:solidFill>
-                <a:latin typeface="Calibri"/>
-              </a:rPr>
-              <a:t>Each temple isolated: own domain, data and branding</a:t>
+              <a:t>Tickets: 'Collect' records a pending payment into the finance ledger; 'Scan ticket' admits devotees.</a:t>
             </a:r>
           </a:p>
         </p:txBody>
@@ -13351,7 +14891,7 @@
                 </a:solidFill>
                 <a:latin typeface="Georgia"/>
               </a:rPr>
-              <a:t>Trust: security and privacy built in</a:t>
+              <a:t>Walkthrough video</a:t>
             </a:r>
           </a:p>
         </p:txBody>
@@ -13364,8 +14904,8 @@
         </p:nvSpPr>
         <p:spPr>
           <a:xfrm>
-            <a:off x="548640" y="6446520"/>
-            <a:ext cx="7315200" cy="274320"/>
+            <a:off x="548640" y="960120"/>
+            <a:ext cx="10972800" cy="457200"/>
           </a:xfrm>
           <a:prstGeom prst="rect">
             <a:avLst/>
@@ -13384,117 +14924,27 @@
               </a:spcAft>
             </a:pPr>
             <a:r>
-              <a:rPr sz="1000" b="0">
-                <a:solidFill>
-                  <a:srgbClr val="887777"/>
-                </a:solidFill>
-                <a:latin typeface="Calibri"/>
-              </a:rPr>
-              <a:t>Temple Platform  |  Vriksha Studio</a:t>
-            </a:r>
-          </a:p>
-        </p:txBody>
-      </p:sp>
-      <p:sp>
-        <p:nvSpPr>
-          <p:cNvPr id="5" name="Rectangle 4"/>
-          <p:cNvSpPr/>
-          <p:nvPr/>
-        </p:nvSpPr>
-        <p:spPr>
-          <a:xfrm>
-            <a:off x="548640" y="1463040"/>
-            <a:ext cx="3611880" cy="2194560"/>
-          </a:xfrm>
-          <a:prstGeom prst="rect">
-            <a:avLst/>
-          </a:prstGeom>
-          <a:solidFill>
-            <a:srgbClr val="FFFFFF"/>
-          </a:solidFill>
-          <a:ln w="12700">
-            <a:solidFill>
-              <a:srgbClr val="E6D9C3"/>
-            </a:solidFill>
-          </a:ln>
-          <a:effectLst/>
-        </p:spPr>
-        <p:style>
-          <a:lnRef idx="1">
-            <a:schemeClr val="accent1"/>
-          </a:lnRef>
-          <a:fillRef idx="3">
-            <a:schemeClr val="accent1"/>
-          </a:fillRef>
-          <a:effectRef idx="2">
-            <a:schemeClr val="accent1"/>
-          </a:effectRef>
-          <a:fontRef idx="minor">
-            <a:schemeClr val="lt1"/>
-          </a:fontRef>
-        </p:style>
-        <p:txBody>
-          <a:bodyPr rtlCol="0" anchor="ctr"/>
-          <a:lstStyle/>
-          <a:p>
-            <a:pPr algn="ctr"/>
-          </a:p>
-        </p:txBody>
-      </p:sp>
-      <p:sp>
-        <p:nvSpPr>
-          <p:cNvPr id="6" name="Rectangle 5"/>
-          <p:cNvSpPr/>
-          <p:nvPr/>
-        </p:nvSpPr>
-        <p:spPr>
-          <a:xfrm>
-            <a:off x="548640" y="1463040"/>
-            <a:ext cx="3611880" cy="91440"/>
-          </a:xfrm>
-          <a:prstGeom prst="rect">
-            <a:avLst/>
-          </a:prstGeom>
-          <a:solidFill>
-            <a:srgbClr val="7B1A1A"/>
-          </a:solidFill>
-          <a:ln>
-            <a:noFill/>
-          </a:ln>
-          <a:effectLst/>
-        </p:spPr>
-        <p:style>
-          <a:lnRef idx="1">
-            <a:schemeClr val="accent1"/>
-          </a:lnRef>
-          <a:fillRef idx="3">
-            <a:schemeClr val="accent1"/>
-          </a:fillRef>
-          <a:effectRef idx="2">
-            <a:schemeClr val="accent1"/>
-          </a:effectRef>
-          <a:fontRef idx="minor">
-            <a:schemeClr val="lt1"/>
-          </a:fontRef>
-        </p:style>
-        <p:txBody>
-          <a:bodyPr rtlCol="0" anchor="ctr"/>
-          <a:lstStyle/>
-          <a:p>
-            <a:pPr algn="ctr"/>
-          </a:p>
-        </p:txBody>
-      </p:sp>
-      <p:sp>
-        <p:nvSpPr>
-          <p:cNvPr id="7" name="TextBox 6"/>
+              <a:rPr sz="1600" b="0">
+                <a:solidFill>
+                  <a:srgbClr val="C87A1E"/>
+                </a:solidFill>
+                <a:latin typeface="Calibri"/>
+              </a:rPr>
+              <a:t>Click to play: public site, sign-in, admin (about 1 min)</a:t>
+            </a:r>
+          </a:p>
+        </p:txBody>
+      </p:sp>
+      <p:sp>
+        <p:nvSpPr>
+          <p:cNvPr id="5" name="TextBox 4"/>
           <p:cNvSpPr txBox="1"/>
           <p:nvPr/>
         </p:nvSpPr>
         <p:spPr>
           <a:xfrm>
-            <a:off x="731520" y="1645920"/>
-            <a:ext cx="3246120" cy="457200"/>
+            <a:off x="548640" y="6446520"/>
+            <a:ext cx="7315200" cy="274320"/>
           </a:xfrm>
           <a:prstGeom prst="rect">
             <a:avLst/>
@@ -13513,901 +14963,77 @@
               </a:spcAft>
             </a:pPr>
             <a:r>
-              <a:rPr sz="1800" b="1">
-                <a:solidFill>
-                  <a:srgbClr val="7B1A1A"/>
-                </a:solidFill>
-                <a:latin typeface="Georgia"/>
-              </a:rPr>
-              <a:t>Access control</a:t>
-            </a:r>
-          </a:p>
-        </p:txBody>
-      </p:sp>
-      <p:sp>
-        <p:nvSpPr>
-          <p:cNvPr id="8" name="TextBox 7"/>
-          <p:cNvSpPr txBox="1"/>
-          <p:nvPr/>
-        </p:nvSpPr>
-        <p:spPr>
-          <a:xfrm>
-            <a:off x="731520" y="2148840"/>
-            <a:ext cx="3246120" cy="1371600"/>
-          </a:xfrm>
-          <a:prstGeom prst="rect">
-            <a:avLst/>
-          </a:prstGeom>
-          <a:noFill/>
-        </p:spPr>
-        <p:txBody>
-          <a:bodyPr wrap="square" anchor="t">
-            <a:spAutoFit/>
-          </a:bodyPr>
-          <a:lstStyle/>
-          <a:p>
-            <a:pPr algn="l">
-              <a:spcAft>
-                <a:spcPts val="600"/>
-              </a:spcAft>
-            </a:pPr>
-            <a:r>
-              <a:rPr sz="1400" b="0">
-                <a:solidFill>
-                  <a:srgbClr val="2B2020"/>
-                </a:solidFill>
-                <a:latin typeface="Calibri"/>
-              </a:rPr>
-              <a:t>Five roles; permissions checked on the server for every action</a:t>
-            </a:r>
-          </a:p>
-        </p:txBody>
-      </p:sp>
-      <p:sp>
-        <p:nvSpPr>
-          <p:cNvPr id="9" name="Rectangle 8"/>
-          <p:cNvSpPr/>
-          <p:nvPr/>
-        </p:nvSpPr>
-        <p:spPr>
-          <a:xfrm>
-            <a:off x="4343400" y="1463040"/>
-            <a:ext cx="3611880" cy="2194560"/>
-          </a:xfrm>
-          <a:prstGeom prst="rect">
-            <a:avLst/>
-          </a:prstGeom>
-          <a:solidFill>
-            <a:srgbClr val="FFFFFF"/>
-          </a:solidFill>
-          <a:ln w="12700">
-            <a:solidFill>
-              <a:srgbClr val="E6D9C3"/>
-            </a:solidFill>
-          </a:ln>
-          <a:effectLst/>
-        </p:spPr>
-        <p:style>
-          <a:lnRef idx="1">
-            <a:schemeClr val="accent1"/>
-          </a:lnRef>
-          <a:fillRef idx="3">
-            <a:schemeClr val="accent1"/>
-          </a:fillRef>
-          <a:effectRef idx="2">
-            <a:schemeClr val="accent1"/>
-          </a:effectRef>
-          <a:fontRef idx="minor">
-            <a:schemeClr val="lt1"/>
-          </a:fontRef>
-        </p:style>
-        <p:txBody>
-          <a:bodyPr rtlCol="0" anchor="ctr"/>
-          <a:lstStyle/>
-          <a:p>
-            <a:pPr algn="ctr"/>
-          </a:p>
-        </p:txBody>
-      </p:sp>
-      <p:sp>
-        <p:nvSpPr>
-          <p:cNvPr id="10" name="Rectangle 9"/>
-          <p:cNvSpPr/>
-          <p:nvPr/>
-        </p:nvSpPr>
-        <p:spPr>
-          <a:xfrm>
-            <a:off x="4343400" y="1463040"/>
-            <a:ext cx="3611880" cy="91440"/>
-          </a:xfrm>
-          <a:prstGeom prst="rect">
-            <a:avLst/>
-          </a:prstGeom>
-          <a:solidFill>
-            <a:srgbClr val="C87A1E"/>
-          </a:solidFill>
-          <a:ln>
-            <a:noFill/>
-          </a:ln>
-          <a:effectLst/>
-        </p:spPr>
-        <p:style>
-          <a:lnRef idx="1">
-            <a:schemeClr val="accent1"/>
-          </a:lnRef>
-          <a:fillRef idx="3">
-            <a:schemeClr val="accent1"/>
-          </a:fillRef>
-          <a:effectRef idx="2">
-            <a:schemeClr val="accent1"/>
-          </a:effectRef>
-          <a:fontRef idx="minor">
-            <a:schemeClr val="lt1"/>
-          </a:fontRef>
-        </p:style>
-        <p:txBody>
-          <a:bodyPr rtlCol="0" anchor="ctr"/>
-          <a:lstStyle/>
-          <a:p>
-            <a:pPr algn="ctr"/>
-          </a:p>
-        </p:txBody>
-      </p:sp>
-      <p:sp>
-        <p:nvSpPr>
-          <p:cNvPr id="11" name="TextBox 10"/>
-          <p:cNvSpPr txBox="1"/>
-          <p:nvPr/>
-        </p:nvSpPr>
-        <p:spPr>
-          <a:xfrm>
-            <a:off x="4526280" y="1645920"/>
-            <a:ext cx="3246120" cy="457200"/>
-          </a:xfrm>
-          <a:prstGeom prst="rect">
-            <a:avLst/>
-          </a:prstGeom>
-          <a:noFill/>
-        </p:spPr>
-        <p:txBody>
-          <a:bodyPr wrap="square" anchor="t">
-            <a:spAutoFit/>
-          </a:bodyPr>
-          <a:lstStyle/>
-          <a:p>
-            <a:pPr algn="l">
-              <a:spcAft>
-                <a:spcPts val="600"/>
-              </a:spcAft>
-            </a:pPr>
-            <a:r>
-              <a:rPr sz="1800" b="1">
-                <a:solidFill>
-                  <a:srgbClr val="C87A1E"/>
-                </a:solidFill>
-                <a:latin typeface="Georgia"/>
-              </a:rPr>
-              <a:t>Two-factor login</a:t>
-            </a:r>
-          </a:p>
-        </p:txBody>
-      </p:sp>
-      <p:sp>
-        <p:nvSpPr>
-          <p:cNvPr id="12" name="TextBox 11"/>
-          <p:cNvSpPr txBox="1"/>
-          <p:nvPr/>
-        </p:nvSpPr>
-        <p:spPr>
-          <a:xfrm>
-            <a:off x="4526280" y="2148840"/>
-            <a:ext cx="3246120" cy="1371600"/>
-          </a:xfrm>
-          <a:prstGeom prst="rect">
-            <a:avLst/>
-          </a:prstGeom>
-          <a:noFill/>
-        </p:spPr>
-        <p:txBody>
-          <a:bodyPr wrap="square" anchor="t">
-            <a:spAutoFit/>
-          </a:bodyPr>
-          <a:lstStyle/>
-          <a:p>
-            <a:pPr algn="l">
-              <a:spcAft>
-                <a:spcPts val="600"/>
-              </a:spcAft>
-            </a:pPr>
-            <a:r>
-              <a:rPr sz="1400" b="0">
-                <a:solidFill>
-                  <a:srgbClr val="2B2020"/>
-                </a:solidFill>
-                <a:latin typeface="Calibri"/>
-              </a:rPr>
-              <a:t>Email OTP; 30-minute idle timeout</a:t>
-            </a:r>
-          </a:p>
-        </p:txBody>
-      </p:sp>
-      <p:sp>
-        <p:nvSpPr>
-          <p:cNvPr id="13" name="Rectangle 12"/>
-          <p:cNvSpPr/>
-          <p:nvPr/>
-        </p:nvSpPr>
-        <p:spPr>
-          <a:xfrm>
-            <a:off x="8138160" y="1463040"/>
-            <a:ext cx="3611880" cy="2194560"/>
-          </a:xfrm>
-          <a:prstGeom prst="rect">
-            <a:avLst/>
-          </a:prstGeom>
-          <a:solidFill>
-            <a:srgbClr val="FFFFFF"/>
-          </a:solidFill>
-          <a:ln w="12700">
-            <a:solidFill>
-              <a:srgbClr val="E6D9C3"/>
-            </a:solidFill>
-          </a:ln>
-          <a:effectLst/>
-        </p:spPr>
-        <p:style>
-          <a:lnRef idx="1">
-            <a:schemeClr val="accent1"/>
-          </a:lnRef>
-          <a:fillRef idx="3">
-            <a:schemeClr val="accent1"/>
-          </a:fillRef>
-          <a:effectRef idx="2">
-            <a:schemeClr val="accent1"/>
-          </a:effectRef>
-          <a:fontRef idx="minor">
-            <a:schemeClr val="lt1"/>
-          </a:fontRef>
-        </p:style>
-        <p:txBody>
-          <a:bodyPr rtlCol="0" anchor="ctr"/>
-          <a:lstStyle/>
-          <a:p>
-            <a:pPr algn="ctr"/>
-          </a:p>
-        </p:txBody>
-      </p:sp>
-      <p:sp>
-        <p:nvSpPr>
-          <p:cNvPr id="14" name="Rectangle 13"/>
-          <p:cNvSpPr/>
-          <p:nvPr/>
-        </p:nvSpPr>
-        <p:spPr>
-          <a:xfrm>
-            <a:off x="8138160" y="1463040"/>
-            <a:ext cx="3611880" cy="91440"/>
-          </a:xfrm>
-          <a:prstGeom prst="rect">
-            <a:avLst/>
-          </a:prstGeom>
-          <a:solidFill>
-            <a:srgbClr val="7B1A1A"/>
-          </a:solidFill>
-          <a:ln>
-            <a:noFill/>
-          </a:ln>
-          <a:effectLst/>
-        </p:spPr>
-        <p:style>
-          <a:lnRef idx="1">
-            <a:schemeClr val="accent1"/>
-          </a:lnRef>
-          <a:fillRef idx="3">
-            <a:schemeClr val="accent1"/>
-          </a:fillRef>
-          <a:effectRef idx="2">
-            <a:schemeClr val="accent1"/>
-          </a:effectRef>
-          <a:fontRef idx="minor">
-            <a:schemeClr val="lt1"/>
-          </a:fontRef>
-        </p:style>
-        <p:txBody>
-          <a:bodyPr rtlCol="0" anchor="ctr"/>
-          <a:lstStyle/>
-          <a:p>
-            <a:pPr algn="ctr"/>
-          </a:p>
-        </p:txBody>
-      </p:sp>
-      <p:sp>
-        <p:nvSpPr>
-          <p:cNvPr id="15" name="TextBox 14"/>
-          <p:cNvSpPr txBox="1"/>
-          <p:nvPr/>
-        </p:nvSpPr>
-        <p:spPr>
-          <a:xfrm>
-            <a:off x="8321040" y="1645920"/>
-            <a:ext cx="3246120" cy="457200"/>
-          </a:xfrm>
-          <a:prstGeom prst="rect">
-            <a:avLst/>
-          </a:prstGeom>
-          <a:noFill/>
-        </p:spPr>
-        <p:txBody>
-          <a:bodyPr wrap="square" anchor="t">
-            <a:spAutoFit/>
-          </a:bodyPr>
-          <a:lstStyle/>
-          <a:p>
-            <a:pPr algn="l">
-              <a:spcAft>
-                <a:spcPts val="600"/>
-              </a:spcAft>
-            </a:pPr>
-            <a:r>
-              <a:rPr sz="1800" b="1">
-                <a:solidFill>
-                  <a:srgbClr val="7B1A1A"/>
-                </a:solidFill>
-                <a:latin typeface="Georgia"/>
-              </a:rPr>
-              <a:t>Audit trail</a:t>
-            </a:r>
-          </a:p>
-        </p:txBody>
-      </p:sp>
-      <p:sp>
-        <p:nvSpPr>
-          <p:cNvPr id="16" name="TextBox 15"/>
-          <p:cNvSpPr txBox="1"/>
-          <p:nvPr/>
-        </p:nvSpPr>
-        <p:spPr>
-          <a:xfrm>
-            <a:off x="8321040" y="2148840"/>
-            <a:ext cx="3246120" cy="1371600"/>
-          </a:xfrm>
-          <a:prstGeom prst="rect">
-            <a:avLst/>
-          </a:prstGeom>
-          <a:noFill/>
-        </p:spPr>
-        <p:txBody>
-          <a:bodyPr wrap="square" anchor="t">
-            <a:spAutoFit/>
-          </a:bodyPr>
-          <a:lstStyle/>
-          <a:p>
-            <a:pPr algn="l">
-              <a:spcAft>
-                <a:spcPts val="600"/>
-              </a:spcAft>
-            </a:pPr>
-            <a:r>
-              <a:rPr sz="1400" b="0">
-                <a:solidFill>
-                  <a:srgbClr val="2B2020"/>
-                </a:solidFill>
-                <a:latin typeface="Calibri"/>
-              </a:rPr>
-              <a:t>Every change recorded; alerts on bulk deletions</a:t>
-            </a:r>
-          </a:p>
-        </p:txBody>
-      </p:sp>
-      <p:sp>
-        <p:nvSpPr>
-          <p:cNvPr id="17" name="Rectangle 16"/>
-          <p:cNvSpPr/>
-          <p:nvPr/>
-        </p:nvSpPr>
-        <p:spPr>
-          <a:xfrm>
-            <a:off x="548640" y="3931920"/>
-            <a:ext cx="3611880" cy="2194560"/>
-          </a:xfrm>
-          <a:prstGeom prst="rect">
-            <a:avLst/>
-          </a:prstGeom>
-          <a:solidFill>
-            <a:srgbClr val="FFFFFF"/>
-          </a:solidFill>
-          <a:ln w="12700">
-            <a:solidFill>
-              <a:srgbClr val="E6D9C3"/>
-            </a:solidFill>
-          </a:ln>
-          <a:effectLst/>
-        </p:spPr>
-        <p:style>
-          <a:lnRef idx="1">
-            <a:schemeClr val="accent1"/>
-          </a:lnRef>
-          <a:fillRef idx="3">
-            <a:schemeClr val="accent1"/>
-          </a:fillRef>
-          <a:effectRef idx="2">
-            <a:schemeClr val="accent1"/>
-          </a:effectRef>
-          <a:fontRef idx="minor">
-            <a:schemeClr val="lt1"/>
-          </a:fontRef>
-        </p:style>
-        <p:txBody>
-          <a:bodyPr rtlCol="0" anchor="ctr"/>
-          <a:lstStyle/>
-          <a:p>
-            <a:pPr algn="ctr"/>
-          </a:p>
-        </p:txBody>
-      </p:sp>
-      <p:sp>
-        <p:nvSpPr>
-          <p:cNvPr id="18" name="Rectangle 17"/>
-          <p:cNvSpPr/>
-          <p:nvPr/>
-        </p:nvSpPr>
-        <p:spPr>
-          <a:xfrm>
-            <a:off x="548640" y="3931920"/>
-            <a:ext cx="3611880" cy="91440"/>
-          </a:xfrm>
-          <a:prstGeom prst="rect">
-            <a:avLst/>
-          </a:prstGeom>
-          <a:solidFill>
-            <a:srgbClr val="C87A1E"/>
-          </a:solidFill>
-          <a:ln>
-            <a:noFill/>
-          </a:ln>
-          <a:effectLst/>
-        </p:spPr>
-        <p:style>
-          <a:lnRef idx="1">
-            <a:schemeClr val="accent1"/>
-          </a:lnRef>
-          <a:fillRef idx="3">
-            <a:schemeClr val="accent1"/>
-          </a:fillRef>
-          <a:effectRef idx="2">
-            <a:schemeClr val="accent1"/>
-          </a:effectRef>
-          <a:fontRef idx="minor">
-            <a:schemeClr val="lt1"/>
-          </a:fontRef>
-        </p:style>
-        <p:txBody>
-          <a:bodyPr rtlCol="0" anchor="ctr"/>
-          <a:lstStyle/>
-          <a:p>
-            <a:pPr algn="ctr"/>
-          </a:p>
-        </p:txBody>
-      </p:sp>
-      <p:sp>
-        <p:nvSpPr>
-          <p:cNvPr id="19" name="TextBox 18"/>
-          <p:cNvSpPr txBox="1"/>
-          <p:nvPr/>
-        </p:nvSpPr>
-        <p:spPr>
-          <a:xfrm>
-            <a:off x="731520" y="4114800"/>
-            <a:ext cx="3246120" cy="457200"/>
-          </a:xfrm>
-          <a:prstGeom prst="rect">
-            <a:avLst/>
-          </a:prstGeom>
-          <a:noFill/>
-        </p:spPr>
-        <p:txBody>
-          <a:bodyPr wrap="square" anchor="t">
-            <a:spAutoFit/>
-          </a:bodyPr>
-          <a:lstStyle/>
-          <a:p>
-            <a:pPr algn="l">
-              <a:spcAft>
-                <a:spcPts val="600"/>
-              </a:spcAft>
-            </a:pPr>
-            <a:r>
-              <a:rPr sz="1800" b="1">
-                <a:solidFill>
-                  <a:srgbClr val="C87A1E"/>
-                </a:solidFill>
-                <a:latin typeface="Georgia"/>
-              </a:rPr>
-              <a:t>Abuse protection</a:t>
-            </a:r>
-          </a:p>
-        </p:txBody>
-      </p:sp>
-      <p:sp>
-        <p:nvSpPr>
-          <p:cNvPr id="20" name="TextBox 19"/>
-          <p:cNvSpPr txBox="1"/>
-          <p:nvPr/>
-        </p:nvSpPr>
-        <p:spPr>
-          <a:xfrm>
-            <a:off x="731520" y="4617720"/>
-            <a:ext cx="3246120" cy="1371600"/>
-          </a:xfrm>
-          <a:prstGeom prst="rect">
-            <a:avLst/>
-          </a:prstGeom>
-          <a:noFill/>
-        </p:spPr>
-        <p:txBody>
-          <a:bodyPr wrap="square" anchor="t">
-            <a:spAutoFit/>
-          </a:bodyPr>
-          <a:lstStyle/>
-          <a:p>
-            <a:pPr algn="l">
-              <a:spcAft>
-                <a:spcPts val="600"/>
-              </a:spcAft>
-            </a:pPr>
-            <a:r>
-              <a:rPr sz="1400" b="0">
-                <a:solidFill>
-                  <a:srgbClr val="2B2020"/>
-                </a:solidFill>
-                <a:latin typeface="Calibri"/>
-              </a:rPr>
-              <a:t>Rate limiting and bot challenge on public forms</a:t>
-            </a:r>
-          </a:p>
-        </p:txBody>
-      </p:sp>
-      <p:sp>
-        <p:nvSpPr>
-          <p:cNvPr id="21" name="Rectangle 20"/>
-          <p:cNvSpPr/>
-          <p:nvPr/>
-        </p:nvSpPr>
-        <p:spPr>
-          <a:xfrm>
-            <a:off x="4343400" y="3931920"/>
-            <a:ext cx="3611880" cy="2194560"/>
-          </a:xfrm>
-          <a:prstGeom prst="rect">
-            <a:avLst/>
-          </a:prstGeom>
-          <a:solidFill>
-            <a:srgbClr val="FFFFFF"/>
-          </a:solidFill>
-          <a:ln w="12700">
-            <a:solidFill>
-              <a:srgbClr val="E6D9C3"/>
-            </a:solidFill>
-          </a:ln>
-          <a:effectLst/>
-        </p:spPr>
-        <p:style>
-          <a:lnRef idx="1">
-            <a:schemeClr val="accent1"/>
-          </a:lnRef>
-          <a:fillRef idx="3">
-            <a:schemeClr val="accent1"/>
-          </a:fillRef>
-          <a:effectRef idx="2">
-            <a:schemeClr val="accent1"/>
-          </a:effectRef>
-          <a:fontRef idx="minor">
-            <a:schemeClr val="lt1"/>
-          </a:fontRef>
-        </p:style>
-        <p:txBody>
-          <a:bodyPr rtlCol="0" anchor="ctr"/>
-          <a:lstStyle/>
-          <a:p>
-            <a:pPr algn="ctr"/>
-          </a:p>
-        </p:txBody>
-      </p:sp>
-      <p:sp>
-        <p:nvSpPr>
-          <p:cNvPr id="22" name="Rectangle 21"/>
-          <p:cNvSpPr/>
-          <p:nvPr/>
-        </p:nvSpPr>
-        <p:spPr>
-          <a:xfrm>
-            <a:off x="4343400" y="3931920"/>
-            <a:ext cx="3611880" cy="91440"/>
-          </a:xfrm>
-          <a:prstGeom prst="rect">
-            <a:avLst/>
-          </a:prstGeom>
-          <a:solidFill>
-            <a:srgbClr val="7B1A1A"/>
-          </a:solidFill>
-          <a:ln>
-            <a:noFill/>
-          </a:ln>
-          <a:effectLst/>
-        </p:spPr>
-        <p:style>
-          <a:lnRef idx="1">
-            <a:schemeClr val="accent1"/>
-          </a:lnRef>
-          <a:fillRef idx="3">
-            <a:schemeClr val="accent1"/>
-          </a:fillRef>
-          <a:effectRef idx="2">
-            <a:schemeClr val="accent1"/>
-          </a:effectRef>
-          <a:fontRef idx="minor">
-            <a:schemeClr val="lt1"/>
-          </a:fontRef>
-        </p:style>
-        <p:txBody>
-          <a:bodyPr rtlCol="0" anchor="ctr"/>
-          <a:lstStyle/>
-          <a:p>
-            <a:pPr algn="ctr"/>
-          </a:p>
-        </p:txBody>
-      </p:sp>
-      <p:sp>
-        <p:nvSpPr>
-          <p:cNvPr id="23" name="TextBox 22"/>
-          <p:cNvSpPr txBox="1"/>
-          <p:nvPr/>
-        </p:nvSpPr>
-        <p:spPr>
-          <a:xfrm>
-            <a:off x="4526280" y="4114800"/>
-            <a:ext cx="3246120" cy="457200"/>
-          </a:xfrm>
-          <a:prstGeom prst="rect">
-            <a:avLst/>
-          </a:prstGeom>
-          <a:noFill/>
-        </p:spPr>
-        <p:txBody>
-          <a:bodyPr wrap="square" anchor="t">
-            <a:spAutoFit/>
-          </a:bodyPr>
-          <a:lstStyle/>
-          <a:p>
-            <a:pPr algn="l">
-              <a:spcAft>
-                <a:spcPts val="600"/>
-              </a:spcAft>
-            </a:pPr>
-            <a:r>
-              <a:rPr sz="1800" b="1">
-                <a:solidFill>
-                  <a:srgbClr val="7B1A1A"/>
-                </a:solidFill>
-                <a:latin typeface="Georgia"/>
-              </a:rPr>
-              <a:t>Privacy (DPDPA)</a:t>
-            </a:r>
-          </a:p>
-        </p:txBody>
-      </p:sp>
-      <p:sp>
-        <p:nvSpPr>
-          <p:cNvPr id="24" name="TextBox 23"/>
-          <p:cNvSpPr txBox="1"/>
-          <p:nvPr/>
-        </p:nvSpPr>
-        <p:spPr>
-          <a:xfrm>
-            <a:off x="4526280" y="4617720"/>
-            <a:ext cx="3246120" cy="1371600"/>
-          </a:xfrm>
-          <a:prstGeom prst="rect">
-            <a:avLst/>
-          </a:prstGeom>
-          <a:noFill/>
-        </p:spPr>
-        <p:txBody>
-          <a:bodyPr wrap="square" anchor="t">
-            <a:spAutoFit/>
-          </a:bodyPr>
-          <a:lstStyle/>
-          <a:p>
-            <a:pPr algn="l">
-              <a:spcAft>
-                <a:spcPts val="600"/>
-              </a:spcAft>
-            </a:pPr>
-            <a:r>
-              <a:rPr sz="1400" b="0">
-                <a:solidFill>
-                  <a:srgbClr val="2B2020"/>
-                </a:solidFill>
-                <a:latin typeface="Calibri"/>
-              </a:rPr>
-              <a:t>Privacy policy on site, emails and tickets</a:t>
-            </a:r>
-          </a:p>
-        </p:txBody>
-      </p:sp>
-      <p:sp>
-        <p:nvSpPr>
-          <p:cNvPr id="25" name="Rectangle 24"/>
-          <p:cNvSpPr/>
-          <p:nvPr/>
-        </p:nvSpPr>
-        <p:spPr>
-          <a:xfrm>
-            <a:off x="8138160" y="3931920"/>
-            <a:ext cx="3611880" cy="2194560"/>
-          </a:xfrm>
-          <a:prstGeom prst="rect">
-            <a:avLst/>
-          </a:prstGeom>
-          <a:solidFill>
-            <a:srgbClr val="FFFFFF"/>
-          </a:solidFill>
-          <a:ln w="12700">
-            <a:solidFill>
-              <a:srgbClr val="E6D9C3"/>
-            </a:solidFill>
-          </a:ln>
-          <a:effectLst/>
-        </p:spPr>
-        <p:style>
-          <a:lnRef idx="1">
-            <a:schemeClr val="accent1"/>
-          </a:lnRef>
-          <a:fillRef idx="3">
-            <a:schemeClr val="accent1"/>
-          </a:fillRef>
-          <a:effectRef idx="2">
-            <a:schemeClr val="accent1"/>
-          </a:effectRef>
-          <a:fontRef idx="minor">
-            <a:schemeClr val="lt1"/>
-          </a:fontRef>
-        </p:style>
-        <p:txBody>
-          <a:bodyPr rtlCol="0" anchor="ctr"/>
-          <a:lstStyle/>
-          <a:p>
-            <a:pPr algn="ctr"/>
-          </a:p>
-        </p:txBody>
-      </p:sp>
-      <p:sp>
-        <p:nvSpPr>
-          <p:cNvPr id="26" name="Rectangle 25"/>
-          <p:cNvSpPr/>
-          <p:nvPr/>
-        </p:nvSpPr>
-        <p:spPr>
-          <a:xfrm>
-            <a:off x="8138160" y="3931920"/>
-            <a:ext cx="3611880" cy="91440"/>
-          </a:xfrm>
-          <a:prstGeom prst="rect">
-            <a:avLst/>
-          </a:prstGeom>
-          <a:solidFill>
-            <a:srgbClr val="C87A1E"/>
-          </a:solidFill>
-          <a:ln>
-            <a:noFill/>
-          </a:ln>
-          <a:effectLst/>
-        </p:spPr>
-        <p:style>
-          <a:lnRef idx="1">
-            <a:schemeClr val="accent1"/>
-          </a:lnRef>
-          <a:fillRef idx="3">
-            <a:schemeClr val="accent1"/>
-          </a:fillRef>
-          <a:effectRef idx="2">
-            <a:schemeClr val="accent1"/>
-          </a:effectRef>
-          <a:fontRef idx="minor">
-            <a:schemeClr val="lt1"/>
-          </a:fontRef>
-        </p:style>
-        <p:txBody>
-          <a:bodyPr rtlCol="0" anchor="ctr"/>
-          <a:lstStyle/>
-          <a:p>
-            <a:pPr algn="ctr"/>
-          </a:p>
-        </p:txBody>
-      </p:sp>
-      <p:sp>
-        <p:nvSpPr>
-          <p:cNvPr id="27" name="TextBox 26"/>
-          <p:cNvSpPr txBox="1"/>
-          <p:nvPr/>
-        </p:nvSpPr>
-        <p:spPr>
-          <a:xfrm>
-            <a:off x="8321040" y="4114800"/>
-            <a:ext cx="3246120" cy="457200"/>
-          </a:xfrm>
-          <a:prstGeom prst="rect">
-            <a:avLst/>
-          </a:prstGeom>
-          <a:noFill/>
-        </p:spPr>
-        <p:txBody>
-          <a:bodyPr wrap="square" anchor="t">
-            <a:spAutoFit/>
-          </a:bodyPr>
-          <a:lstStyle/>
-          <a:p>
-            <a:pPr algn="l">
-              <a:spcAft>
-                <a:spcPts val="600"/>
-              </a:spcAft>
-            </a:pPr>
-            <a:r>
-              <a:rPr sz="1800" b="1">
-                <a:solidFill>
-                  <a:srgbClr val="C87A1E"/>
-                </a:solidFill>
-                <a:latin typeface="Georgia"/>
-              </a:rPr>
-              <a:t>Safe by default</a:t>
-            </a:r>
-          </a:p>
-        </p:txBody>
-      </p:sp>
-      <p:sp>
-        <p:nvSpPr>
-          <p:cNvPr id="28" name="TextBox 27"/>
-          <p:cNvSpPr txBox="1"/>
-          <p:nvPr/>
-        </p:nvSpPr>
-        <p:spPr>
-          <a:xfrm>
-            <a:off x="8321040" y="4617720"/>
-            <a:ext cx="3246120" cy="1371600"/>
-          </a:xfrm>
-          <a:prstGeom prst="rect">
-            <a:avLst/>
-          </a:prstGeom>
-          <a:noFill/>
-        </p:spPr>
-        <p:txBody>
-          <a:bodyPr wrap="square" anchor="t">
-            <a:spAutoFit/>
-          </a:bodyPr>
-          <a:lstStyle/>
-          <a:p>
-            <a:pPr algn="l">
-              <a:spcAft>
-                <a:spcPts val="600"/>
-              </a:spcAft>
-            </a:pPr>
-            <a:r>
-              <a:rPr sz="1400" b="0">
-                <a:solidFill>
-                  <a:srgbClr val="2B2020"/>
-                </a:solidFill>
-                <a:latin typeface="Calibri"/>
-              </a:rPr>
-              <a:t>HTTPS, hashed passwords, no AWS keys in app, dependency audits</a:t>
-            </a:r>
-          </a:p>
-        </p:txBody>
-      </p:sp>
+              <a:rPr sz="1000" b="0">
+                <a:solidFill>
+                  <a:srgbClr val="887777"/>
+                </a:solidFill>
+                <a:latin typeface="Calibri"/>
+              </a:rPr>
+              <a:t>Temple Platform  |  Vriksha Studio</a:t>
+            </a:r>
+          </a:p>
+        </p:txBody>
+      </p:sp>
+      <p:pic>
+        <p:nvPicPr>
+          <p:cNvPr id="6" name="walkthrough.mp4">
+            <a:hlinkClick r:id="" action="ppaction://media"/>
+          </p:cNvPr>
+          <p:cNvPicPr>
+            <a:picLocks noChangeAspect="1"/>
+          </p:cNvPicPr>
+          <p:nvPr>
+            <a:videoFile r:link="rId3"/>
+            <p:extLst>
+              <p:ext uri="{DAA4B4D4-6D71-4841-9C94-3DE7FCFB9230}">
+                <p14:media xmlns:p14="http://schemas.microsoft.com/office/powerpoint/2010/main" r:embed="rId2"/>
+              </p:ext>
+            </p:extLst>
+          </p:nvPr>
+        </p:nvPicPr>
+        <p:blipFill>
+          <a:blip r:embed="rId4"/>
+          <a:stretch>
+            <a:fillRect/>
+          </a:stretch>
+        </p:blipFill>
+        <p:spPr>
+          <a:xfrm>
+            <a:off x="2240280" y="1463040"/>
+            <a:ext cx="7680960" cy="4800600"/>
+          </a:xfrm>
+          <a:prstGeom prst="rect">
+            <a:avLst/>
+          </a:prstGeom>
+        </p:spPr>
+      </p:pic>
     </p:spTree>
   </p:cSld>
   <p:clrMapOvr>
     <a:masterClrMapping/>
   </p:clrMapOvr>
+  <p:timing>
+    <p:tnLst>
+      <p:par>
+        <p:cTn id="1" dur="indefinite" restart="never" nodeType="tmRoot">
+          <p:childTnLst>
+            <p:video>
+              <p:cMediaNode vol="80000">
+                <p:cTn id="2" fill="hold" display="0">
+                  <p:stCondLst>
+                    <p:cond delay="indefinite"/>
+                  </p:stCondLst>
+                </p:cTn>
+                <p:tgtEl>
+                  <p:spTgt spid="6"/>
+                </p:tgtEl>
+              </p:cMediaNode>
+            </p:video>
+          </p:childTnLst>
+        </p:cTn>
+      </p:par>
+    </p:tnLst>
+  </p:timing>
 </p:sld>
 </file>
 

</xml_diff>